<commit_message>
add documentation for wireless numeric keypads
</commit_message>
<xml_diff>
--- a/documentation/orinayo_views.pptx
+++ b/documentation/orinayo_views.pptx
@@ -4,12 +4,16 @@
   <p:sldMasterIdLst>
     <p:sldMasterId id="2147483648" r:id="rId1"/>
   </p:sldMasterIdLst>
+  <p:notesMasterIdLst>
+    <p:notesMasterId r:id="rId8"/>
+  </p:notesMasterIdLst>
   <p:sldIdLst>
     <p:sldId id="256" r:id="rId2"/>
     <p:sldId id="257" r:id="rId3"/>
     <p:sldId id="258" r:id="rId4"/>
     <p:sldId id="259" r:id="rId5"/>
     <p:sldId id="260" r:id="rId6"/>
+    <p:sldId id="261" r:id="rId7"/>
   </p:sldIdLst>
   <p:sldSz cx="12192000" cy="6858000"/>
   <p:notesSz cx="6858000" cy="9144000"/>
@@ -116,6 +120,440 @@
 </p:presentation>
 </file>
 
+<file path=ppt/notesMasters/notesMaster1.xml><?xml version="1.0" encoding="utf-8"?>
+<p:notesMaster xmlns:a="http://schemas.openxmlformats.org/drawingml/2006/main" xmlns:r="http://schemas.openxmlformats.org/officeDocument/2006/relationships" xmlns:p="http://schemas.openxmlformats.org/presentationml/2006/main">
+  <p:cSld>
+    <p:bg>
+      <p:bgRef idx="1001">
+        <a:schemeClr val="bg1"/>
+      </p:bgRef>
+    </p:bg>
+    <p:spTree>
+      <p:nvGrpSpPr>
+        <p:cNvPr id="1" name=""/>
+        <p:cNvGrpSpPr/>
+        <p:nvPr/>
+      </p:nvGrpSpPr>
+      <p:grpSpPr>
+        <a:xfrm>
+          <a:off x="0" y="0"/>
+          <a:ext cx="0" cy="0"/>
+          <a:chOff x="0" y="0"/>
+          <a:chExt cx="0" cy="0"/>
+        </a:xfrm>
+      </p:grpSpPr>
+      <p:sp>
+        <p:nvSpPr>
+          <p:cNvPr id="2" name="Header Placeholder 1"/>
+          <p:cNvSpPr>
+            <a:spLocks noGrp="1"/>
+          </p:cNvSpPr>
+          <p:nvPr>
+            <p:ph type="hdr" sz="quarter"/>
+          </p:nvPr>
+        </p:nvSpPr>
+        <p:spPr>
+          <a:xfrm>
+            <a:off x="0" y="0"/>
+            <a:ext cx="2971800" cy="458788"/>
+          </a:xfrm>
+          <a:prstGeom prst="rect">
+            <a:avLst/>
+          </a:prstGeom>
+        </p:spPr>
+        <p:txBody>
+          <a:bodyPr vert="horz" lIns="91440" tIns="45720" rIns="91440" bIns="45720" rtlCol="0"/>
+          <a:lstStyle>
+            <a:lvl1pPr algn="l">
+              <a:defRPr sz="1200"/>
+            </a:lvl1pPr>
+          </a:lstStyle>
+          <a:p>
+            <a:endParaRPr lang="en-GB"/>
+          </a:p>
+        </p:txBody>
+      </p:sp>
+      <p:sp>
+        <p:nvSpPr>
+          <p:cNvPr id="3" name="Date Placeholder 2"/>
+          <p:cNvSpPr>
+            <a:spLocks noGrp="1"/>
+          </p:cNvSpPr>
+          <p:nvPr>
+            <p:ph type="dt" idx="1"/>
+          </p:nvPr>
+        </p:nvSpPr>
+        <p:spPr>
+          <a:xfrm>
+            <a:off x="3884613" y="0"/>
+            <a:ext cx="2971800" cy="458788"/>
+          </a:xfrm>
+          <a:prstGeom prst="rect">
+            <a:avLst/>
+          </a:prstGeom>
+        </p:spPr>
+        <p:txBody>
+          <a:bodyPr vert="horz" lIns="91440" tIns="45720" rIns="91440" bIns="45720" rtlCol="0"/>
+          <a:lstStyle>
+            <a:lvl1pPr algn="r">
+              <a:defRPr sz="1200"/>
+            </a:lvl1pPr>
+          </a:lstStyle>
+          <a:p>
+            <a:fld id="{D3021C03-3599-4634-B5FC-63937472D69E}" type="datetimeFigureOut">
+              <a:rPr lang="en-GB" smtClean="0"/>
+              <a:t>11/03/2025</a:t>
+            </a:fld>
+            <a:endParaRPr lang="en-GB"/>
+          </a:p>
+        </p:txBody>
+      </p:sp>
+      <p:sp>
+        <p:nvSpPr>
+          <p:cNvPr id="4" name="Slide Image Placeholder 3"/>
+          <p:cNvSpPr>
+            <a:spLocks noGrp="1" noRot="1" noChangeAspect="1"/>
+          </p:cNvSpPr>
+          <p:nvPr>
+            <p:ph type="sldImg" idx="2"/>
+          </p:nvPr>
+        </p:nvSpPr>
+        <p:spPr>
+          <a:xfrm>
+            <a:off x="685800" y="1143000"/>
+            <a:ext cx="5486400" cy="3086100"/>
+          </a:xfrm>
+          <a:prstGeom prst="rect">
+            <a:avLst/>
+          </a:prstGeom>
+          <a:noFill/>
+          <a:ln w="12700">
+            <a:solidFill>
+              <a:prstClr val="black"/>
+            </a:solidFill>
+          </a:ln>
+        </p:spPr>
+        <p:txBody>
+          <a:bodyPr vert="horz" lIns="91440" tIns="45720" rIns="91440" bIns="45720" rtlCol="0" anchor="ctr"/>
+          <a:lstStyle/>
+          <a:p>
+            <a:endParaRPr lang="en-GB"/>
+          </a:p>
+        </p:txBody>
+      </p:sp>
+      <p:sp>
+        <p:nvSpPr>
+          <p:cNvPr id="5" name="Notes Placeholder 4"/>
+          <p:cNvSpPr>
+            <a:spLocks noGrp="1"/>
+          </p:cNvSpPr>
+          <p:nvPr>
+            <p:ph type="body" sz="quarter" idx="3"/>
+          </p:nvPr>
+        </p:nvSpPr>
+        <p:spPr>
+          <a:xfrm>
+            <a:off x="685800" y="4400550"/>
+            <a:ext cx="5486400" cy="3600450"/>
+          </a:xfrm>
+          <a:prstGeom prst="rect">
+            <a:avLst/>
+          </a:prstGeom>
+        </p:spPr>
+        <p:txBody>
+          <a:bodyPr vert="horz" lIns="91440" tIns="45720" rIns="91440" bIns="45720" rtlCol="0"/>
+          <a:lstStyle/>
+          <a:p>
+            <a:pPr lvl="0"/>
+            <a:r>
+              <a:rPr lang="en-US"/>
+              <a:t>Click to edit Master text styles</a:t>
+            </a:r>
+          </a:p>
+          <a:p>
+            <a:pPr lvl="1"/>
+            <a:r>
+              <a:rPr lang="en-US"/>
+              <a:t>Second level</a:t>
+            </a:r>
+          </a:p>
+          <a:p>
+            <a:pPr lvl="2"/>
+            <a:r>
+              <a:rPr lang="en-US"/>
+              <a:t>Third level</a:t>
+            </a:r>
+          </a:p>
+          <a:p>
+            <a:pPr lvl="3"/>
+            <a:r>
+              <a:rPr lang="en-US"/>
+              <a:t>Fourth level</a:t>
+            </a:r>
+          </a:p>
+          <a:p>
+            <a:pPr lvl="4"/>
+            <a:r>
+              <a:rPr lang="en-US"/>
+              <a:t>Fifth level</a:t>
+            </a:r>
+            <a:endParaRPr lang="en-GB"/>
+          </a:p>
+        </p:txBody>
+      </p:sp>
+      <p:sp>
+        <p:nvSpPr>
+          <p:cNvPr id="6" name="Footer Placeholder 5"/>
+          <p:cNvSpPr>
+            <a:spLocks noGrp="1"/>
+          </p:cNvSpPr>
+          <p:nvPr>
+            <p:ph type="ftr" sz="quarter" idx="4"/>
+          </p:nvPr>
+        </p:nvSpPr>
+        <p:spPr>
+          <a:xfrm>
+            <a:off x="0" y="8685213"/>
+            <a:ext cx="2971800" cy="458787"/>
+          </a:xfrm>
+          <a:prstGeom prst="rect">
+            <a:avLst/>
+          </a:prstGeom>
+        </p:spPr>
+        <p:txBody>
+          <a:bodyPr vert="horz" lIns="91440" tIns="45720" rIns="91440" bIns="45720" rtlCol="0" anchor="b"/>
+          <a:lstStyle>
+            <a:lvl1pPr algn="l">
+              <a:defRPr sz="1200"/>
+            </a:lvl1pPr>
+          </a:lstStyle>
+          <a:p>
+            <a:endParaRPr lang="en-GB"/>
+          </a:p>
+        </p:txBody>
+      </p:sp>
+      <p:sp>
+        <p:nvSpPr>
+          <p:cNvPr id="7" name="Slide Number Placeholder 6"/>
+          <p:cNvSpPr>
+            <a:spLocks noGrp="1"/>
+          </p:cNvSpPr>
+          <p:nvPr>
+            <p:ph type="sldNum" sz="quarter" idx="5"/>
+          </p:nvPr>
+        </p:nvSpPr>
+        <p:spPr>
+          <a:xfrm>
+            <a:off x="3884613" y="8685213"/>
+            <a:ext cx="2971800" cy="458787"/>
+          </a:xfrm>
+          <a:prstGeom prst="rect">
+            <a:avLst/>
+          </a:prstGeom>
+        </p:spPr>
+        <p:txBody>
+          <a:bodyPr vert="horz" lIns="91440" tIns="45720" rIns="91440" bIns="45720" rtlCol="0" anchor="b"/>
+          <a:lstStyle>
+            <a:lvl1pPr algn="r">
+              <a:defRPr sz="1200"/>
+            </a:lvl1pPr>
+          </a:lstStyle>
+          <a:p>
+            <a:fld id="{ACD1DDBB-A4DB-4B16-9BD5-EC09926B64B1}" type="slidenum">
+              <a:rPr lang="en-GB" smtClean="0"/>
+              <a:t>‹#›</a:t>
+            </a:fld>
+            <a:endParaRPr lang="en-GB"/>
+          </a:p>
+        </p:txBody>
+      </p:sp>
+    </p:spTree>
+    <p:extLst>
+      <p:ext uri="{BB962C8B-B14F-4D97-AF65-F5344CB8AC3E}">
+        <p14:creationId xmlns:p14="http://schemas.microsoft.com/office/powerpoint/2010/main" val="1438977403"/>
+      </p:ext>
+    </p:extLst>
+  </p:cSld>
+  <p:clrMap bg1="lt1" tx1="dk1" bg2="lt2" tx2="dk2" accent1="accent1" accent2="accent2" accent3="accent3" accent4="accent4" accent5="accent5" accent6="accent6" hlink="hlink" folHlink="folHlink"/>
+  <p:notesStyle>
+    <a:lvl1pPr marL="0" algn="l" defTabSz="914400" rtl="0" eaLnBrk="1" latinLnBrk="0" hangingPunct="1">
+      <a:defRPr sz="1200" kern="1200">
+        <a:solidFill>
+          <a:schemeClr val="tx1"/>
+        </a:solidFill>
+        <a:latin typeface="+mn-lt"/>
+        <a:ea typeface="+mn-ea"/>
+        <a:cs typeface="+mn-cs"/>
+      </a:defRPr>
+    </a:lvl1pPr>
+    <a:lvl2pPr marL="457200" algn="l" defTabSz="914400" rtl="0" eaLnBrk="1" latinLnBrk="0" hangingPunct="1">
+      <a:defRPr sz="1200" kern="1200">
+        <a:solidFill>
+          <a:schemeClr val="tx1"/>
+        </a:solidFill>
+        <a:latin typeface="+mn-lt"/>
+        <a:ea typeface="+mn-ea"/>
+        <a:cs typeface="+mn-cs"/>
+      </a:defRPr>
+    </a:lvl2pPr>
+    <a:lvl3pPr marL="914400" algn="l" defTabSz="914400" rtl="0" eaLnBrk="1" latinLnBrk="0" hangingPunct="1">
+      <a:defRPr sz="1200" kern="1200">
+        <a:solidFill>
+          <a:schemeClr val="tx1"/>
+        </a:solidFill>
+        <a:latin typeface="+mn-lt"/>
+        <a:ea typeface="+mn-ea"/>
+        <a:cs typeface="+mn-cs"/>
+      </a:defRPr>
+    </a:lvl3pPr>
+    <a:lvl4pPr marL="1371600" algn="l" defTabSz="914400" rtl="0" eaLnBrk="1" latinLnBrk="0" hangingPunct="1">
+      <a:defRPr sz="1200" kern="1200">
+        <a:solidFill>
+          <a:schemeClr val="tx1"/>
+        </a:solidFill>
+        <a:latin typeface="+mn-lt"/>
+        <a:ea typeface="+mn-ea"/>
+        <a:cs typeface="+mn-cs"/>
+      </a:defRPr>
+    </a:lvl4pPr>
+    <a:lvl5pPr marL="1828800" algn="l" defTabSz="914400" rtl="0" eaLnBrk="1" latinLnBrk="0" hangingPunct="1">
+      <a:defRPr sz="1200" kern="1200">
+        <a:solidFill>
+          <a:schemeClr val="tx1"/>
+        </a:solidFill>
+        <a:latin typeface="+mn-lt"/>
+        <a:ea typeface="+mn-ea"/>
+        <a:cs typeface="+mn-cs"/>
+      </a:defRPr>
+    </a:lvl5pPr>
+    <a:lvl6pPr marL="2286000" algn="l" defTabSz="914400" rtl="0" eaLnBrk="1" latinLnBrk="0" hangingPunct="1">
+      <a:defRPr sz="1200" kern="1200">
+        <a:solidFill>
+          <a:schemeClr val="tx1"/>
+        </a:solidFill>
+        <a:latin typeface="+mn-lt"/>
+        <a:ea typeface="+mn-ea"/>
+        <a:cs typeface="+mn-cs"/>
+      </a:defRPr>
+    </a:lvl6pPr>
+    <a:lvl7pPr marL="2743200" algn="l" defTabSz="914400" rtl="0" eaLnBrk="1" latinLnBrk="0" hangingPunct="1">
+      <a:defRPr sz="1200" kern="1200">
+        <a:solidFill>
+          <a:schemeClr val="tx1"/>
+        </a:solidFill>
+        <a:latin typeface="+mn-lt"/>
+        <a:ea typeface="+mn-ea"/>
+        <a:cs typeface="+mn-cs"/>
+      </a:defRPr>
+    </a:lvl7pPr>
+    <a:lvl8pPr marL="3200400" algn="l" defTabSz="914400" rtl="0" eaLnBrk="1" latinLnBrk="0" hangingPunct="1">
+      <a:defRPr sz="1200" kern="1200">
+        <a:solidFill>
+          <a:schemeClr val="tx1"/>
+        </a:solidFill>
+        <a:latin typeface="+mn-lt"/>
+        <a:ea typeface="+mn-ea"/>
+        <a:cs typeface="+mn-cs"/>
+      </a:defRPr>
+    </a:lvl8pPr>
+    <a:lvl9pPr marL="3657600" algn="l" defTabSz="914400" rtl="0" eaLnBrk="1" latinLnBrk="0" hangingPunct="1">
+      <a:defRPr sz="1200" kern="1200">
+        <a:solidFill>
+          <a:schemeClr val="tx1"/>
+        </a:solidFill>
+        <a:latin typeface="+mn-lt"/>
+        <a:ea typeface="+mn-ea"/>
+        <a:cs typeface="+mn-cs"/>
+      </a:defRPr>
+    </a:lvl9pPr>
+  </p:notesStyle>
+</p:notesMaster>
+</file>
+
+<file path=ppt/notesSlides/notesSlide1.xml><?xml version="1.0" encoding="utf-8"?>
+<p:notes xmlns:a="http://schemas.openxmlformats.org/drawingml/2006/main" xmlns:r="http://schemas.openxmlformats.org/officeDocument/2006/relationships" xmlns:p="http://schemas.openxmlformats.org/presentationml/2006/main">
+  <p:cSld>
+    <p:spTree>
+      <p:nvGrpSpPr>
+        <p:cNvPr id="1" name=""/>
+        <p:cNvGrpSpPr/>
+        <p:nvPr/>
+      </p:nvGrpSpPr>
+      <p:grpSpPr>
+        <a:xfrm>
+          <a:off x="0" y="0"/>
+          <a:ext cx="0" cy="0"/>
+          <a:chOff x="0" y="0"/>
+          <a:chExt cx="0" cy="0"/>
+        </a:xfrm>
+      </p:grpSpPr>
+      <p:sp>
+        <p:nvSpPr>
+          <p:cNvPr id="2" name="Slide Image Placeholder 1"/>
+          <p:cNvSpPr>
+            <a:spLocks noGrp="1" noRot="1" noChangeAspect="1"/>
+          </p:cNvSpPr>
+          <p:nvPr>
+            <p:ph type="sldImg"/>
+          </p:nvPr>
+        </p:nvSpPr>
+        <p:spPr/>
+      </p:sp>
+      <p:sp>
+        <p:nvSpPr>
+          <p:cNvPr id="3" name="Notes Placeholder 2"/>
+          <p:cNvSpPr>
+            <a:spLocks noGrp="1"/>
+          </p:cNvSpPr>
+          <p:nvPr>
+            <p:ph type="body" idx="1"/>
+          </p:nvPr>
+        </p:nvSpPr>
+        <p:spPr/>
+        <p:txBody>
+          <a:bodyPr/>
+          <a:lstStyle/>
+          <a:p>
+            <a:endParaRPr lang="en-GB" dirty="0"/>
+          </a:p>
+        </p:txBody>
+      </p:sp>
+      <p:sp>
+        <p:nvSpPr>
+          <p:cNvPr id="4" name="Slide Number Placeholder 3"/>
+          <p:cNvSpPr>
+            <a:spLocks noGrp="1"/>
+          </p:cNvSpPr>
+          <p:nvPr>
+            <p:ph type="sldNum" sz="quarter" idx="5"/>
+          </p:nvPr>
+        </p:nvSpPr>
+        <p:spPr/>
+        <p:txBody>
+          <a:bodyPr/>
+          <a:lstStyle/>
+          <a:p>
+            <a:fld id="{ACD1DDBB-A4DB-4B16-9BD5-EC09926B64B1}" type="slidenum">
+              <a:rPr lang="en-GB" smtClean="0"/>
+              <a:t>6</a:t>
+            </a:fld>
+            <a:endParaRPr lang="en-GB"/>
+          </a:p>
+        </p:txBody>
+      </p:sp>
+    </p:spTree>
+    <p:extLst>
+      <p:ext uri="{BB962C8B-B14F-4D97-AF65-F5344CB8AC3E}">
+        <p14:creationId xmlns:p14="http://schemas.microsoft.com/office/powerpoint/2010/main" val="2501295607"/>
+      </p:ext>
+    </p:extLst>
+  </p:cSld>
+  <p:clrMapOvr>
+    <a:masterClrMapping/>
+  </p:clrMapOvr>
+</p:notes>
+</file>
+
 <file path=ppt/slideLayouts/slideLayout1.xml><?xml version="1.0" encoding="utf-8"?>
 <p:sldLayout xmlns:a="http://schemas.openxmlformats.org/drawingml/2006/main" xmlns:r="http://schemas.openxmlformats.org/officeDocument/2006/relationships" xmlns:p="http://schemas.openxmlformats.org/presentationml/2006/main" type="title" preserve="1">
   <p:cSld name="Title Slide">
@@ -265,7 +703,7 @@
           <a:p>
             <a:fld id="{C1C7C397-5798-4899-9405-F71757EE535D}" type="datetimeFigureOut">
               <a:rPr lang="en-GB" smtClean="0"/>
-              <a:t>10/03/2025</a:t>
+              <a:t>11/03/2025</a:t>
             </a:fld>
             <a:endParaRPr lang="en-GB"/>
           </a:p>
@@ -465,7 +903,7 @@
           <a:p>
             <a:fld id="{C1C7C397-5798-4899-9405-F71757EE535D}" type="datetimeFigureOut">
               <a:rPr lang="en-GB" smtClean="0"/>
-              <a:t>10/03/2025</a:t>
+              <a:t>11/03/2025</a:t>
             </a:fld>
             <a:endParaRPr lang="en-GB"/>
           </a:p>
@@ -675,7 +1113,7 @@
           <a:p>
             <a:fld id="{C1C7C397-5798-4899-9405-F71757EE535D}" type="datetimeFigureOut">
               <a:rPr lang="en-GB" smtClean="0"/>
-              <a:t>10/03/2025</a:t>
+              <a:t>11/03/2025</a:t>
             </a:fld>
             <a:endParaRPr lang="en-GB"/>
           </a:p>
@@ -875,7 +1313,7 @@
           <a:p>
             <a:fld id="{C1C7C397-5798-4899-9405-F71757EE535D}" type="datetimeFigureOut">
               <a:rPr lang="en-GB" smtClean="0"/>
-              <a:t>10/03/2025</a:t>
+              <a:t>11/03/2025</a:t>
             </a:fld>
             <a:endParaRPr lang="en-GB"/>
           </a:p>
@@ -1151,7 +1589,7 @@
           <a:p>
             <a:fld id="{C1C7C397-5798-4899-9405-F71757EE535D}" type="datetimeFigureOut">
               <a:rPr lang="en-GB" smtClean="0"/>
-              <a:t>10/03/2025</a:t>
+              <a:t>11/03/2025</a:t>
             </a:fld>
             <a:endParaRPr lang="en-GB"/>
           </a:p>
@@ -1419,7 +1857,7 @@
           <a:p>
             <a:fld id="{C1C7C397-5798-4899-9405-F71757EE535D}" type="datetimeFigureOut">
               <a:rPr lang="en-GB" smtClean="0"/>
-              <a:t>10/03/2025</a:t>
+              <a:t>11/03/2025</a:t>
             </a:fld>
             <a:endParaRPr lang="en-GB"/>
           </a:p>
@@ -1834,7 +2272,7 @@
           <a:p>
             <a:fld id="{C1C7C397-5798-4899-9405-F71757EE535D}" type="datetimeFigureOut">
               <a:rPr lang="en-GB" smtClean="0"/>
-              <a:t>10/03/2025</a:t>
+              <a:t>11/03/2025</a:t>
             </a:fld>
             <a:endParaRPr lang="en-GB"/>
           </a:p>
@@ -1976,7 +2414,7 @@
           <a:p>
             <a:fld id="{C1C7C397-5798-4899-9405-F71757EE535D}" type="datetimeFigureOut">
               <a:rPr lang="en-GB" smtClean="0"/>
-              <a:t>10/03/2025</a:t>
+              <a:t>11/03/2025</a:t>
             </a:fld>
             <a:endParaRPr lang="en-GB"/>
           </a:p>
@@ -2089,7 +2527,7 @@
           <a:p>
             <a:fld id="{C1C7C397-5798-4899-9405-F71757EE535D}" type="datetimeFigureOut">
               <a:rPr lang="en-GB" smtClean="0"/>
-              <a:t>10/03/2025</a:t>
+              <a:t>11/03/2025</a:t>
             </a:fld>
             <a:endParaRPr lang="en-GB"/>
           </a:p>
@@ -2402,7 +2840,7 @@
           <a:p>
             <a:fld id="{C1C7C397-5798-4899-9405-F71757EE535D}" type="datetimeFigureOut">
               <a:rPr lang="en-GB" smtClean="0"/>
-              <a:t>10/03/2025</a:t>
+              <a:t>11/03/2025</a:t>
             </a:fld>
             <a:endParaRPr lang="en-GB"/>
           </a:p>
@@ -2691,7 +3129,7 @@
           <a:p>
             <a:fld id="{C1C7C397-5798-4899-9405-F71757EE535D}" type="datetimeFigureOut">
               <a:rPr lang="en-GB" smtClean="0"/>
-              <a:t>10/03/2025</a:t>
+              <a:t>11/03/2025</a:t>
             </a:fld>
             <a:endParaRPr lang="en-GB"/>
           </a:p>
@@ -2934,7 +3372,7 @@
           <a:p>
             <a:fld id="{C1C7C397-5798-4899-9405-F71757EE535D}" type="datetimeFigureOut">
               <a:rPr lang="en-GB" smtClean="0"/>
-              <a:t>10/03/2025</a:t>
+              <a:t>11/03/2025</a:t>
             </a:fld>
             <a:endParaRPr lang="en-GB"/>
           </a:p>
@@ -10168,6 +10606,1735 @@
 </p:sld>
 </file>
 
+<file path=ppt/slides/slide6.xml><?xml version="1.0" encoding="utf-8"?>
+<p:sld xmlns:a="http://schemas.openxmlformats.org/drawingml/2006/main" xmlns:r="http://schemas.openxmlformats.org/officeDocument/2006/relationships" xmlns:p="http://schemas.openxmlformats.org/presentationml/2006/main">
+  <p:cSld>
+    <p:spTree>
+      <p:nvGrpSpPr>
+        <p:cNvPr id="1" name=""/>
+        <p:cNvGrpSpPr/>
+        <p:nvPr/>
+      </p:nvGrpSpPr>
+      <p:grpSpPr>
+        <a:xfrm>
+          <a:off x="0" y="0"/>
+          <a:ext cx="0" cy="0"/>
+          <a:chOff x="0" y="0"/>
+          <a:chExt cx="0" cy="0"/>
+        </a:xfrm>
+      </p:grpSpPr>
+      <p:pic>
+        <p:nvPicPr>
+          <p:cNvPr id="5" name="Picture 4">
+            <a:extLst>
+              <a:ext uri="{FF2B5EF4-FFF2-40B4-BE49-F238E27FC236}">
+                <a16:creationId xmlns:a16="http://schemas.microsoft.com/office/drawing/2014/main" id="{000BDE62-9723-F420-0B80-57B860147BB0}"/>
+              </a:ext>
+            </a:extLst>
+          </p:cNvPr>
+          <p:cNvPicPr>
+            <a:picLocks noChangeAspect="1"/>
+          </p:cNvPicPr>
+          <p:nvPr/>
+        </p:nvPicPr>
+        <p:blipFill>
+          <a:blip r:embed="rId3"/>
+          <a:stretch>
+            <a:fillRect/>
+          </a:stretch>
+        </p:blipFill>
+        <p:spPr>
+          <a:xfrm>
+            <a:off x="4562261" y="323542"/>
+            <a:ext cx="3067478" cy="4382112"/>
+          </a:xfrm>
+          <a:prstGeom prst="rect">
+            <a:avLst/>
+          </a:prstGeom>
+        </p:spPr>
+      </p:pic>
+      <p:grpSp>
+        <p:nvGrpSpPr>
+          <p:cNvPr id="9" name="Group 8">
+            <a:extLst>
+              <a:ext uri="{FF2B5EF4-FFF2-40B4-BE49-F238E27FC236}">
+                <a16:creationId xmlns:a16="http://schemas.microsoft.com/office/drawing/2014/main" id="{6154E422-D744-0E02-521E-9EF6E035D982}"/>
+              </a:ext>
+            </a:extLst>
+          </p:cNvPr>
+          <p:cNvGrpSpPr/>
+          <p:nvPr/>
+        </p:nvGrpSpPr>
+        <p:grpSpPr>
+          <a:xfrm>
+            <a:off x="7334576" y="4186939"/>
+            <a:ext cx="2266281" cy="307777"/>
+            <a:chOff x="9158752" y="5900377"/>
+            <a:chExt cx="2266281" cy="307777"/>
+          </a:xfrm>
+        </p:grpSpPr>
+        <p:cxnSp>
+          <p:nvCxnSpPr>
+            <p:cNvPr id="10" name="Straight Connector 9">
+              <a:extLst>
+                <a:ext uri="{FF2B5EF4-FFF2-40B4-BE49-F238E27FC236}">
+                  <a16:creationId xmlns:a16="http://schemas.microsoft.com/office/drawing/2014/main" id="{BB9AB6ED-C06B-7E56-0C02-2743651A2E8D}"/>
+                </a:ext>
+              </a:extLst>
+            </p:cNvPr>
+            <p:cNvCxnSpPr/>
+            <p:nvPr/>
+          </p:nvCxnSpPr>
+          <p:spPr>
+            <a:xfrm>
+              <a:off x="9158752" y="6054266"/>
+              <a:ext cx="1229032" cy="0"/>
+            </a:xfrm>
+            <a:prstGeom prst="line">
+              <a:avLst/>
+            </a:prstGeom>
+            <a:ln w="3175">
+              <a:headEnd type="triangle" w="med" len="med"/>
+              <a:tailEnd type="none" w="med" len="med"/>
+            </a:ln>
+          </p:spPr>
+          <p:style>
+            <a:lnRef idx="3">
+              <a:schemeClr val="accent2"/>
+            </a:lnRef>
+            <a:fillRef idx="0">
+              <a:schemeClr val="accent2"/>
+            </a:fillRef>
+            <a:effectRef idx="2">
+              <a:schemeClr val="accent2"/>
+            </a:effectRef>
+            <a:fontRef idx="minor">
+              <a:schemeClr val="tx1"/>
+            </a:fontRef>
+          </p:style>
+        </p:cxnSp>
+        <p:sp>
+          <p:nvSpPr>
+            <p:cNvPr id="11" name="TextBox 10">
+              <a:extLst>
+                <a:ext uri="{FF2B5EF4-FFF2-40B4-BE49-F238E27FC236}">
+                  <a16:creationId xmlns:a16="http://schemas.microsoft.com/office/drawing/2014/main" id="{8369279D-4417-3364-7D97-E812334CAA97}"/>
+                </a:ext>
+              </a:extLst>
+            </p:cNvPr>
+            <p:cNvSpPr txBox="1"/>
+            <p:nvPr/>
+          </p:nvSpPr>
+          <p:spPr>
+            <a:xfrm>
+              <a:off x="10376348" y="5900377"/>
+              <a:ext cx="1048685" cy="307777"/>
+            </a:xfrm>
+            <a:prstGeom prst="rect">
+              <a:avLst/>
+            </a:prstGeom>
+            <a:noFill/>
+          </p:spPr>
+          <p:txBody>
+            <a:bodyPr wrap="none" rtlCol="0">
+              <a:spAutoFit/>
+            </a:bodyPr>
+            <a:lstStyle/>
+            <a:p>
+              <a:r>
+                <a:rPr lang="en-GB" sz="1400" dirty="0"/>
+                <a:t>Start / Stop</a:t>
+              </a:r>
+            </a:p>
+          </p:txBody>
+        </p:sp>
+      </p:grpSp>
+      <p:grpSp>
+        <p:nvGrpSpPr>
+          <p:cNvPr id="12" name="Group 11">
+            <a:extLst>
+              <a:ext uri="{FF2B5EF4-FFF2-40B4-BE49-F238E27FC236}">
+                <a16:creationId xmlns:a16="http://schemas.microsoft.com/office/drawing/2014/main" id="{2AFFA2AE-7943-42E4-A434-F8B81AB5FA0D}"/>
+              </a:ext>
+            </a:extLst>
+          </p:cNvPr>
+          <p:cNvGrpSpPr/>
+          <p:nvPr/>
+        </p:nvGrpSpPr>
+        <p:grpSpPr>
+          <a:xfrm>
+            <a:off x="7323140" y="2790745"/>
+            <a:ext cx="2458064" cy="307777"/>
+            <a:chOff x="9158752" y="5900377"/>
+            <a:chExt cx="2458064" cy="307777"/>
+          </a:xfrm>
+        </p:grpSpPr>
+        <p:cxnSp>
+          <p:nvCxnSpPr>
+            <p:cNvPr id="13" name="Straight Connector 12">
+              <a:extLst>
+                <a:ext uri="{FF2B5EF4-FFF2-40B4-BE49-F238E27FC236}">
+                  <a16:creationId xmlns:a16="http://schemas.microsoft.com/office/drawing/2014/main" id="{1ADE66AE-1057-29DC-621D-766CC94DC4D5}"/>
+                </a:ext>
+              </a:extLst>
+            </p:cNvPr>
+            <p:cNvCxnSpPr/>
+            <p:nvPr/>
+          </p:nvCxnSpPr>
+          <p:spPr>
+            <a:xfrm>
+              <a:off x="9158752" y="6054266"/>
+              <a:ext cx="1229032" cy="0"/>
+            </a:xfrm>
+            <a:prstGeom prst="line">
+              <a:avLst/>
+            </a:prstGeom>
+            <a:ln w="3175">
+              <a:headEnd type="triangle" w="med" len="med"/>
+              <a:tailEnd type="none" w="med" len="med"/>
+            </a:ln>
+          </p:spPr>
+          <p:style>
+            <a:lnRef idx="3">
+              <a:schemeClr val="accent2"/>
+            </a:lnRef>
+            <a:fillRef idx="0">
+              <a:schemeClr val="accent2"/>
+            </a:fillRef>
+            <a:effectRef idx="2">
+              <a:schemeClr val="accent2"/>
+            </a:effectRef>
+            <a:fontRef idx="minor">
+              <a:schemeClr val="tx1"/>
+            </a:fontRef>
+          </p:style>
+        </p:cxnSp>
+        <p:sp>
+          <p:nvSpPr>
+            <p:cNvPr id="14" name="TextBox 13">
+              <a:extLst>
+                <a:ext uri="{FF2B5EF4-FFF2-40B4-BE49-F238E27FC236}">
+                  <a16:creationId xmlns:a16="http://schemas.microsoft.com/office/drawing/2014/main" id="{A78E6697-0CF9-3C93-95BA-5D050CF839C3}"/>
+                </a:ext>
+              </a:extLst>
+            </p:cNvPr>
+            <p:cNvSpPr txBox="1"/>
+            <p:nvPr/>
+          </p:nvSpPr>
+          <p:spPr>
+            <a:xfrm>
+              <a:off x="10376348" y="5900377"/>
+              <a:ext cx="1240468" cy="307777"/>
+            </a:xfrm>
+            <a:prstGeom prst="rect">
+              <a:avLst/>
+            </a:prstGeom>
+            <a:noFill/>
+          </p:spPr>
+          <p:txBody>
+            <a:bodyPr wrap="none" rtlCol="0">
+              <a:spAutoFit/>
+            </a:bodyPr>
+            <a:lstStyle/>
+            <a:p>
+              <a:r>
+                <a:rPr lang="en-GB" sz="1400" dirty="0"/>
+                <a:t>Transpose Up</a:t>
+              </a:r>
+            </a:p>
+          </p:txBody>
+        </p:sp>
+      </p:grpSp>
+      <p:grpSp>
+        <p:nvGrpSpPr>
+          <p:cNvPr id="15" name="Group 14">
+            <a:extLst>
+              <a:ext uri="{FF2B5EF4-FFF2-40B4-BE49-F238E27FC236}">
+                <a16:creationId xmlns:a16="http://schemas.microsoft.com/office/drawing/2014/main" id="{5B380232-3379-2BE3-36E0-C2C8EA3A3322}"/>
+              </a:ext>
+            </a:extLst>
+          </p:cNvPr>
+          <p:cNvGrpSpPr/>
+          <p:nvPr/>
+        </p:nvGrpSpPr>
+        <p:grpSpPr>
+          <a:xfrm>
+            <a:off x="7229453" y="2047868"/>
+            <a:ext cx="2685562" cy="307777"/>
+            <a:chOff x="9158752" y="5900377"/>
+            <a:chExt cx="2685562" cy="307777"/>
+          </a:xfrm>
+        </p:grpSpPr>
+        <p:cxnSp>
+          <p:nvCxnSpPr>
+            <p:cNvPr id="16" name="Straight Connector 15">
+              <a:extLst>
+                <a:ext uri="{FF2B5EF4-FFF2-40B4-BE49-F238E27FC236}">
+                  <a16:creationId xmlns:a16="http://schemas.microsoft.com/office/drawing/2014/main" id="{08AF0E09-3AFF-D8E4-4C8E-FEFDA03134CD}"/>
+                </a:ext>
+              </a:extLst>
+            </p:cNvPr>
+            <p:cNvCxnSpPr/>
+            <p:nvPr/>
+          </p:nvCxnSpPr>
+          <p:spPr>
+            <a:xfrm>
+              <a:off x="9158752" y="6054266"/>
+              <a:ext cx="1229032" cy="0"/>
+            </a:xfrm>
+            <a:prstGeom prst="line">
+              <a:avLst/>
+            </a:prstGeom>
+            <a:ln w="3175">
+              <a:headEnd type="triangle" w="med" len="med"/>
+              <a:tailEnd type="none" w="med" len="med"/>
+            </a:ln>
+          </p:spPr>
+          <p:style>
+            <a:lnRef idx="3">
+              <a:schemeClr val="accent2"/>
+            </a:lnRef>
+            <a:fillRef idx="0">
+              <a:schemeClr val="accent2"/>
+            </a:fillRef>
+            <a:effectRef idx="2">
+              <a:schemeClr val="accent2"/>
+            </a:effectRef>
+            <a:fontRef idx="minor">
+              <a:schemeClr val="tx1"/>
+            </a:fontRef>
+          </p:style>
+        </p:cxnSp>
+        <p:sp>
+          <p:nvSpPr>
+            <p:cNvPr id="17" name="TextBox 16">
+              <a:extLst>
+                <a:ext uri="{FF2B5EF4-FFF2-40B4-BE49-F238E27FC236}">
+                  <a16:creationId xmlns:a16="http://schemas.microsoft.com/office/drawing/2014/main" id="{1E93701D-9EE1-50B3-E8DE-4E9C2098CA07}"/>
+                </a:ext>
+              </a:extLst>
+            </p:cNvPr>
+            <p:cNvSpPr txBox="1"/>
+            <p:nvPr/>
+          </p:nvSpPr>
+          <p:spPr>
+            <a:xfrm>
+              <a:off x="10376348" y="5900377"/>
+              <a:ext cx="1467966" cy="307777"/>
+            </a:xfrm>
+            <a:prstGeom prst="rect">
+              <a:avLst/>
+            </a:prstGeom>
+            <a:noFill/>
+          </p:spPr>
+          <p:txBody>
+            <a:bodyPr wrap="none" rtlCol="0">
+              <a:spAutoFit/>
+            </a:bodyPr>
+            <a:lstStyle/>
+            <a:p>
+              <a:r>
+                <a:rPr lang="en-GB" sz="1400" dirty="0"/>
+                <a:t>Transpose Down</a:t>
+              </a:r>
+            </a:p>
+          </p:txBody>
+        </p:sp>
+      </p:grpSp>
+      <p:grpSp>
+        <p:nvGrpSpPr>
+          <p:cNvPr id="18" name="Group 17">
+            <a:extLst>
+              <a:ext uri="{FF2B5EF4-FFF2-40B4-BE49-F238E27FC236}">
+                <a16:creationId xmlns:a16="http://schemas.microsoft.com/office/drawing/2014/main" id="{75187284-07CD-57C0-C423-B9AE3A200591}"/>
+              </a:ext>
+            </a:extLst>
+          </p:cNvPr>
+          <p:cNvGrpSpPr/>
+          <p:nvPr/>
+        </p:nvGrpSpPr>
+        <p:grpSpPr>
+          <a:xfrm>
+            <a:off x="6580018" y="1824968"/>
+            <a:ext cx="1655536" cy="307777"/>
+            <a:chOff x="9158752" y="5900377"/>
+            <a:chExt cx="1655536" cy="307777"/>
+          </a:xfrm>
+        </p:grpSpPr>
+        <p:cxnSp>
+          <p:nvCxnSpPr>
+            <p:cNvPr id="19" name="Straight Connector 18">
+              <a:extLst>
+                <a:ext uri="{FF2B5EF4-FFF2-40B4-BE49-F238E27FC236}">
+                  <a16:creationId xmlns:a16="http://schemas.microsoft.com/office/drawing/2014/main" id="{17FC2145-D8CC-27F0-84CE-311F4A968146}"/>
+                </a:ext>
+              </a:extLst>
+            </p:cNvPr>
+            <p:cNvCxnSpPr/>
+            <p:nvPr/>
+          </p:nvCxnSpPr>
+          <p:spPr>
+            <a:xfrm>
+              <a:off x="9158752" y="6054266"/>
+              <a:ext cx="1229032" cy="0"/>
+            </a:xfrm>
+            <a:prstGeom prst="line">
+              <a:avLst/>
+            </a:prstGeom>
+            <a:ln w="3175">
+              <a:headEnd type="triangle" w="med" len="med"/>
+              <a:tailEnd type="none" w="med" len="med"/>
+            </a:ln>
+          </p:spPr>
+          <p:style>
+            <a:lnRef idx="3">
+              <a:schemeClr val="accent2"/>
+            </a:lnRef>
+            <a:fillRef idx="0">
+              <a:schemeClr val="accent2"/>
+            </a:fillRef>
+            <a:effectRef idx="2">
+              <a:schemeClr val="accent2"/>
+            </a:effectRef>
+            <a:fontRef idx="minor">
+              <a:schemeClr val="tx1"/>
+            </a:fontRef>
+          </p:style>
+        </p:cxnSp>
+        <p:sp>
+          <p:nvSpPr>
+            <p:cNvPr id="20" name="TextBox 19">
+              <a:extLst>
+                <a:ext uri="{FF2B5EF4-FFF2-40B4-BE49-F238E27FC236}">
+                  <a16:creationId xmlns:a16="http://schemas.microsoft.com/office/drawing/2014/main" id="{AFDD83C9-8FF4-11F5-3A57-F3248316E9F1}"/>
+                </a:ext>
+              </a:extLst>
+            </p:cNvPr>
+            <p:cNvSpPr txBox="1"/>
+            <p:nvPr/>
+          </p:nvSpPr>
+          <p:spPr>
+            <a:xfrm>
+              <a:off x="10376348" y="5900377"/>
+              <a:ext cx="437940" cy="307777"/>
+            </a:xfrm>
+            <a:prstGeom prst="rect">
+              <a:avLst/>
+            </a:prstGeom>
+            <a:noFill/>
+          </p:spPr>
+          <p:txBody>
+            <a:bodyPr wrap="none" rtlCol="0">
+              <a:spAutoFit/>
+            </a:bodyPr>
+            <a:lstStyle/>
+            <a:p>
+              <a:r>
+                <a:rPr lang="en-GB" sz="1400" dirty="0"/>
+                <a:t>5/7</a:t>
+              </a:r>
+            </a:p>
+          </p:txBody>
+        </p:sp>
+      </p:grpSp>
+      <p:grpSp>
+        <p:nvGrpSpPr>
+          <p:cNvPr id="21" name="Group 20">
+            <a:extLst>
+              <a:ext uri="{FF2B5EF4-FFF2-40B4-BE49-F238E27FC236}">
+                <a16:creationId xmlns:a16="http://schemas.microsoft.com/office/drawing/2014/main" id="{88B89DFA-C72E-C70A-0F9D-A89A4865AE70}"/>
+              </a:ext>
+            </a:extLst>
+          </p:cNvPr>
+          <p:cNvGrpSpPr/>
+          <p:nvPr/>
+        </p:nvGrpSpPr>
+        <p:grpSpPr>
+          <a:xfrm>
+            <a:off x="6496598" y="3895027"/>
+            <a:ext cx="2903570" cy="307777"/>
+            <a:chOff x="9158752" y="5900377"/>
+            <a:chExt cx="2903570" cy="307777"/>
+          </a:xfrm>
+        </p:grpSpPr>
+        <p:cxnSp>
+          <p:nvCxnSpPr>
+            <p:cNvPr id="22" name="Straight Connector 21">
+              <a:extLst>
+                <a:ext uri="{FF2B5EF4-FFF2-40B4-BE49-F238E27FC236}">
+                  <a16:creationId xmlns:a16="http://schemas.microsoft.com/office/drawing/2014/main" id="{2C17A6E6-BED9-46A5-0EA1-AD4D07C0BE95}"/>
+                </a:ext>
+              </a:extLst>
+            </p:cNvPr>
+            <p:cNvCxnSpPr/>
+            <p:nvPr/>
+          </p:nvCxnSpPr>
+          <p:spPr>
+            <a:xfrm>
+              <a:off x="9158752" y="6054266"/>
+              <a:ext cx="1229032" cy="0"/>
+            </a:xfrm>
+            <a:prstGeom prst="line">
+              <a:avLst/>
+            </a:prstGeom>
+            <a:ln w="3175">
+              <a:headEnd type="triangle" w="med" len="med"/>
+              <a:tailEnd type="none" w="med" len="med"/>
+            </a:ln>
+          </p:spPr>
+          <p:style>
+            <a:lnRef idx="3">
+              <a:schemeClr val="accent2"/>
+            </a:lnRef>
+            <a:fillRef idx="0">
+              <a:schemeClr val="accent2"/>
+            </a:fillRef>
+            <a:effectRef idx="2">
+              <a:schemeClr val="accent2"/>
+            </a:effectRef>
+            <a:fontRef idx="minor">
+              <a:schemeClr val="tx1"/>
+            </a:fontRef>
+          </p:style>
+        </p:cxnSp>
+        <p:sp>
+          <p:nvSpPr>
+            <p:cNvPr id="23" name="TextBox 22">
+              <a:extLst>
+                <a:ext uri="{FF2B5EF4-FFF2-40B4-BE49-F238E27FC236}">
+                  <a16:creationId xmlns:a16="http://schemas.microsoft.com/office/drawing/2014/main" id="{0AB0DF87-8B8C-1B76-B9A0-4F9266364DA8}"/>
+                </a:ext>
+              </a:extLst>
+            </p:cNvPr>
+            <p:cNvSpPr txBox="1"/>
+            <p:nvPr/>
+          </p:nvSpPr>
+          <p:spPr>
+            <a:xfrm>
+              <a:off x="10376348" y="5900377"/>
+              <a:ext cx="1685974" cy="307777"/>
+            </a:xfrm>
+            <a:prstGeom prst="rect">
+              <a:avLst/>
+            </a:prstGeom>
+            <a:noFill/>
+          </p:spPr>
+          <p:txBody>
+            <a:bodyPr wrap="none" rtlCol="0">
+              <a:spAutoFit/>
+            </a:bodyPr>
+            <a:lstStyle/>
+            <a:p>
+              <a:r>
+                <a:rPr lang="en-GB" sz="1400" dirty="0"/>
+                <a:t>Next Style Variation</a:t>
+              </a:r>
+            </a:p>
+          </p:txBody>
+        </p:sp>
+      </p:grpSp>
+      <p:grpSp>
+        <p:nvGrpSpPr>
+          <p:cNvPr id="24" name="Group 23">
+            <a:extLst>
+              <a:ext uri="{FF2B5EF4-FFF2-40B4-BE49-F238E27FC236}">
+                <a16:creationId xmlns:a16="http://schemas.microsoft.com/office/drawing/2014/main" id="{01DC6DAC-9AB9-8F19-D546-544021190672}"/>
+              </a:ext>
+            </a:extLst>
+          </p:cNvPr>
+          <p:cNvGrpSpPr/>
+          <p:nvPr/>
+        </p:nvGrpSpPr>
+        <p:grpSpPr>
+          <a:xfrm>
+            <a:off x="6496598" y="1264896"/>
+            <a:ext cx="1599432" cy="307777"/>
+            <a:chOff x="9158752" y="5900377"/>
+            <a:chExt cx="1599432" cy="307777"/>
+          </a:xfrm>
+        </p:grpSpPr>
+        <p:cxnSp>
+          <p:nvCxnSpPr>
+            <p:cNvPr id="25" name="Straight Connector 24">
+              <a:extLst>
+                <a:ext uri="{FF2B5EF4-FFF2-40B4-BE49-F238E27FC236}">
+                  <a16:creationId xmlns:a16="http://schemas.microsoft.com/office/drawing/2014/main" id="{307BBBB5-D45C-F4E5-6B6B-C6B2C21CE82C}"/>
+                </a:ext>
+              </a:extLst>
+            </p:cNvPr>
+            <p:cNvCxnSpPr/>
+            <p:nvPr/>
+          </p:nvCxnSpPr>
+          <p:spPr>
+            <a:xfrm>
+              <a:off x="9158752" y="6054266"/>
+              <a:ext cx="1229032" cy="0"/>
+            </a:xfrm>
+            <a:prstGeom prst="line">
+              <a:avLst/>
+            </a:prstGeom>
+            <a:ln w="3175">
+              <a:headEnd type="triangle" w="med" len="med"/>
+              <a:tailEnd type="none" w="med" len="med"/>
+            </a:ln>
+          </p:spPr>
+          <p:style>
+            <a:lnRef idx="3">
+              <a:schemeClr val="accent2"/>
+            </a:lnRef>
+            <a:fillRef idx="0">
+              <a:schemeClr val="accent2"/>
+            </a:fillRef>
+            <a:effectRef idx="2">
+              <a:schemeClr val="accent2"/>
+            </a:effectRef>
+            <a:fontRef idx="minor">
+              <a:schemeClr val="tx1"/>
+            </a:fontRef>
+          </p:style>
+        </p:cxnSp>
+        <p:sp>
+          <p:nvSpPr>
+            <p:cNvPr id="26" name="TextBox 25">
+              <a:extLst>
+                <a:ext uri="{FF2B5EF4-FFF2-40B4-BE49-F238E27FC236}">
+                  <a16:creationId xmlns:a16="http://schemas.microsoft.com/office/drawing/2014/main" id="{63C7B76C-2F8E-F040-4383-A3041131D8B8}"/>
+                </a:ext>
+              </a:extLst>
+            </p:cNvPr>
+            <p:cNvSpPr txBox="1"/>
+            <p:nvPr/>
+          </p:nvSpPr>
+          <p:spPr>
+            <a:xfrm>
+              <a:off x="10376348" y="5900377"/>
+              <a:ext cx="381836" cy="307777"/>
+            </a:xfrm>
+            <a:prstGeom prst="rect">
+              <a:avLst/>
+            </a:prstGeom>
+            <a:noFill/>
+          </p:spPr>
+          <p:txBody>
+            <a:bodyPr wrap="none" rtlCol="0">
+              <a:spAutoFit/>
+            </a:bodyPr>
+            <a:lstStyle/>
+            <a:p>
+              <a:r>
+                <a:rPr lang="en-GB" sz="1400" dirty="0"/>
+                <a:t>7b</a:t>
+              </a:r>
+            </a:p>
+          </p:txBody>
+        </p:sp>
+      </p:grpSp>
+      <p:grpSp>
+        <p:nvGrpSpPr>
+          <p:cNvPr id="27" name="Group 26">
+            <a:extLst>
+              <a:ext uri="{FF2B5EF4-FFF2-40B4-BE49-F238E27FC236}">
+                <a16:creationId xmlns:a16="http://schemas.microsoft.com/office/drawing/2014/main" id="{72355A11-8E2D-EE45-4847-FC11EDD3F310}"/>
+              </a:ext>
+            </a:extLst>
+          </p:cNvPr>
+          <p:cNvGrpSpPr/>
+          <p:nvPr/>
+        </p:nvGrpSpPr>
+        <p:grpSpPr>
+          <a:xfrm>
+            <a:off x="6592489" y="2578544"/>
+            <a:ext cx="1655536" cy="307777"/>
+            <a:chOff x="9158752" y="5900377"/>
+            <a:chExt cx="1655536" cy="307777"/>
+          </a:xfrm>
+        </p:grpSpPr>
+        <p:cxnSp>
+          <p:nvCxnSpPr>
+            <p:cNvPr id="28" name="Straight Connector 27">
+              <a:extLst>
+                <a:ext uri="{FF2B5EF4-FFF2-40B4-BE49-F238E27FC236}">
+                  <a16:creationId xmlns:a16="http://schemas.microsoft.com/office/drawing/2014/main" id="{F1071021-B3E5-EFD7-4256-0C04A3C1B561}"/>
+                </a:ext>
+              </a:extLst>
+            </p:cNvPr>
+            <p:cNvCxnSpPr/>
+            <p:nvPr/>
+          </p:nvCxnSpPr>
+          <p:spPr>
+            <a:xfrm>
+              <a:off x="9158752" y="6054266"/>
+              <a:ext cx="1229032" cy="0"/>
+            </a:xfrm>
+            <a:prstGeom prst="line">
+              <a:avLst/>
+            </a:prstGeom>
+            <a:ln w="3175">
+              <a:headEnd type="triangle" w="med" len="med"/>
+              <a:tailEnd type="none" w="med" len="med"/>
+            </a:ln>
+          </p:spPr>
+          <p:style>
+            <a:lnRef idx="3">
+              <a:schemeClr val="accent2"/>
+            </a:lnRef>
+            <a:fillRef idx="0">
+              <a:schemeClr val="accent2"/>
+            </a:fillRef>
+            <a:effectRef idx="2">
+              <a:schemeClr val="accent2"/>
+            </a:effectRef>
+            <a:fontRef idx="minor">
+              <a:schemeClr val="tx1"/>
+            </a:fontRef>
+          </p:style>
+        </p:cxnSp>
+        <p:sp>
+          <p:nvSpPr>
+            <p:cNvPr id="29" name="TextBox 28">
+              <a:extLst>
+                <a:ext uri="{FF2B5EF4-FFF2-40B4-BE49-F238E27FC236}">
+                  <a16:creationId xmlns:a16="http://schemas.microsoft.com/office/drawing/2014/main" id="{7D2625D9-405A-3C44-584C-6851D3F68440}"/>
+                </a:ext>
+              </a:extLst>
+            </p:cNvPr>
+            <p:cNvSpPr txBox="1"/>
+            <p:nvPr/>
+          </p:nvSpPr>
+          <p:spPr>
+            <a:xfrm>
+              <a:off x="10376348" y="5900377"/>
+              <a:ext cx="437940" cy="307777"/>
+            </a:xfrm>
+            <a:prstGeom prst="rect">
+              <a:avLst/>
+            </a:prstGeom>
+            <a:noFill/>
+          </p:spPr>
+          <p:txBody>
+            <a:bodyPr wrap="none" rtlCol="0">
+              <a:spAutoFit/>
+            </a:bodyPr>
+            <a:lstStyle/>
+            <a:p>
+              <a:r>
+                <a:rPr lang="en-GB" sz="1400" dirty="0"/>
+                <a:t>1/3</a:t>
+              </a:r>
+            </a:p>
+          </p:txBody>
+        </p:sp>
+      </p:grpSp>
+      <p:grpSp>
+        <p:nvGrpSpPr>
+          <p:cNvPr id="30" name="Group 29">
+            <a:extLst>
+              <a:ext uri="{FF2B5EF4-FFF2-40B4-BE49-F238E27FC236}">
+                <a16:creationId xmlns:a16="http://schemas.microsoft.com/office/drawing/2014/main" id="{100117AE-2673-B304-0B45-E076221579E3}"/>
+              </a:ext>
+            </a:extLst>
+          </p:cNvPr>
+          <p:cNvGrpSpPr/>
+          <p:nvPr/>
+        </p:nvGrpSpPr>
+        <p:grpSpPr>
+          <a:xfrm>
+            <a:off x="6607239" y="3242222"/>
+            <a:ext cx="1655536" cy="307777"/>
+            <a:chOff x="9158752" y="5900377"/>
+            <a:chExt cx="1655536" cy="307777"/>
+          </a:xfrm>
+        </p:grpSpPr>
+        <p:cxnSp>
+          <p:nvCxnSpPr>
+            <p:cNvPr id="31" name="Straight Connector 30">
+              <a:extLst>
+                <a:ext uri="{FF2B5EF4-FFF2-40B4-BE49-F238E27FC236}">
+                  <a16:creationId xmlns:a16="http://schemas.microsoft.com/office/drawing/2014/main" id="{1D149D99-41D3-087F-3BA3-E401EA06BFFA}"/>
+                </a:ext>
+              </a:extLst>
+            </p:cNvPr>
+            <p:cNvCxnSpPr/>
+            <p:nvPr/>
+          </p:nvCxnSpPr>
+          <p:spPr>
+            <a:xfrm>
+              <a:off x="9158752" y="6054266"/>
+              <a:ext cx="1229032" cy="0"/>
+            </a:xfrm>
+            <a:prstGeom prst="line">
+              <a:avLst/>
+            </a:prstGeom>
+            <a:ln w="3175">
+              <a:headEnd type="triangle" w="med" len="med"/>
+              <a:tailEnd type="none" w="med" len="med"/>
+            </a:ln>
+          </p:spPr>
+          <p:style>
+            <a:lnRef idx="3">
+              <a:schemeClr val="accent2"/>
+            </a:lnRef>
+            <a:fillRef idx="0">
+              <a:schemeClr val="accent2"/>
+            </a:fillRef>
+            <a:effectRef idx="2">
+              <a:schemeClr val="accent2"/>
+            </a:effectRef>
+            <a:fontRef idx="minor">
+              <a:schemeClr val="tx1"/>
+            </a:fontRef>
+          </p:style>
+        </p:cxnSp>
+        <p:sp>
+          <p:nvSpPr>
+            <p:cNvPr id="32" name="TextBox 31">
+              <a:extLst>
+                <a:ext uri="{FF2B5EF4-FFF2-40B4-BE49-F238E27FC236}">
+                  <a16:creationId xmlns:a16="http://schemas.microsoft.com/office/drawing/2014/main" id="{69E4BB4A-C54C-6D2E-11C0-CC9BB9129504}"/>
+                </a:ext>
+              </a:extLst>
+            </p:cNvPr>
+            <p:cNvSpPr txBox="1"/>
+            <p:nvPr/>
+          </p:nvSpPr>
+          <p:spPr>
+            <a:xfrm>
+              <a:off x="10376348" y="5900377"/>
+              <a:ext cx="437940" cy="307777"/>
+            </a:xfrm>
+            <a:prstGeom prst="rect">
+              <a:avLst/>
+            </a:prstGeom>
+            <a:noFill/>
+          </p:spPr>
+          <p:txBody>
+            <a:bodyPr wrap="none" rtlCol="0">
+              <a:spAutoFit/>
+            </a:bodyPr>
+            <a:lstStyle/>
+            <a:p>
+              <a:r>
+                <a:rPr lang="en-GB" sz="1400" dirty="0"/>
+                <a:t>4/6</a:t>
+              </a:r>
+            </a:p>
+          </p:txBody>
+        </p:sp>
+      </p:grpSp>
+      <p:grpSp>
+        <p:nvGrpSpPr>
+          <p:cNvPr id="33" name="Group 32">
+            <a:extLst>
+              <a:ext uri="{FF2B5EF4-FFF2-40B4-BE49-F238E27FC236}">
+                <a16:creationId xmlns:a16="http://schemas.microsoft.com/office/drawing/2014/main" id="{6D4AF823-4286-8A9E-6471-54D835D0D1EB}"/>
+              </a:ext>
+            </a:extLst>
+          </p:cNvPr>
+          <p:cNvGrpSpPr/>
+          <p:nvPr/>
+        </p:nvGrpSpPr>
+        <p:grpSpPr>
+          <a:xfrm>
+            <a:off x="2476206" y="4105855"/>
+            <a:ext cx="2435631" cy="307777"/>
+            <a:chOff x="169917" y="284862"/>
+            <a:chExt cx="2435631" cy="307777"/>
+          </a:xfrm>
+        </p:grpSpPr>
+        <p:cxnSp>
+          <p:nvCxnSpPr>
+            <p:cNvPr id="34" name="Straight Connector 33">
+              <a:extLst>
+                <a:ext uri="{FF2B5EF4-FFF2-40B4-BE49-F238E27FC236}">
+                  <a16:creationId xmlns:a16="http://schemas.microsoft.com/office/drawing/2014/main" id="{BD73E3E2-9D87-D447-C125-9EF22B086BDD}"/>
+                </a:ext>
+              </a:extLst>
+            </p:cNvPr>
+            <p:cNvCxnSpPr/>
+            <p:nvPr/>
+          </p:nvCxnSpPr>
+          <p:spPr>
+            <a:xfrm>
+              <a:off x="1376516" y="422789"/>
+              <a:ext cx="1229032" cy="0"/>
+            </a:xfrm>
+            <a:prstGeom prst="line">
+              <a:avLst/>
+            </a:prstGeom>
+            <a:ln w="3175">
+              <a:headEnd type="none" w="med" len="med"/>
+              <a:tailEnd type="triangle" w="med" len="med"/>
+            </a:ln>
+          </p:spPr>
+          <p:style>
+            <a:lnRef idx="3">
+              <a:schemeClr val="accent2"/>
+            </a:lnRef>
+            <a:fillRef idx="0">
+              <a:schemeClr val="accent2"/>
+            </a:fillRef>
+            <a:effectRef idx="2">
+              <a:schemeClr val="accent2"/>
+            </a:effectRef>
+            <a:fontRef idx="minor">
+              <a:schemeClr val="tx1"/>
+            </a:fontRef>
+          </p:style>
+        </p:cxnSp>
+        <p:sp>
+          <p:nvSpPr>
+            <p:cNvPr id="35" name="TextBox 34">
+              <a:extLst>
+                <a:ext uri="{FF2B5EF4-FFF2-40B4-BE49-F238E27FC236}">
+                  <a16:creationId xmlns:a16="http://schemas.microsoft.com/office/drawing/2014/main" id="{F2B88158-D378-0785-532E-B450AF7722D7}"/>
+                </a:ext>
+              </a:extLst>
+            </p:cNvPr>
+            <p:cNvSpPr txBox="1"/>
+            <p:nvPr/>
+          </p:nvSpPr>
+          <p:spPr>
+            <a:xfrm>
+              <a:off x="169917" y="284862"/>
+              <a:ext cx="1268745" cy="307777"/>
+            </a:xfrm>
+            <a:prstGeom prst="rect">
+              <a:avLst/>
+            </a:prstGeom>
+            <a:noFill/>
+          </p:spPr>
+          <p:txBody>
+            <a:bodyPr wrap="none" rtlCol="0">
+              <a:spAutoFit/>
+            </a:bodyPr>
+            <a:lstStyle/>
+            <a:p>
+              <a:r>
+                <a:rPr lang="en-GB" sz="1400" dirty="0"/>
+                <a:t>Previous Style</a:t>
+              </a:r>
+            </a:p>
+          </p:txBody>
+        </p:sp>
+      </p:grpSp>
+      <p:grpSp>
+        <p:nvGrpSpPr>
+          <p:cNvPr id="36" name="Group 35">
+            <a:extLst>
+              <a:ext uri="{FF2B5EF4-FFF2-40B4-BE49-F238E27FC236}">
+                <a16:creationId xmlns:a16="http://schemas.microsoft.com/office/drawing/2014/main" id="{49003A72-EF9B-F2FD-6BCD-F00A6AEE9374}"/>
+              </a:ext>
+            </a:extLst>
+          </p:cNvPr>
+          <p:cNvGrpSpPr/>
+          <p:nvPr/>
+        </p:nvGrpSpPr>
+        <p:grpSpPr>
+          <a:xfrm>
+            <a:off x="4152605" y="3501167"/>
+            <a:ext cx="1491734" cy="307777"/>
+            <a:chOff x="1113814" y="284862"/>
+            <a:chExt cx="1491734" cy="307777"/>
+          </a:xfrm>
+        </p:grpSpPr>
+        <p:cxnSp>
+          <p:nvCxnSpPr>
+            <p:cNvPr id="37" name="Straight Connector 36">
+              <a:extLst>
+                <a:ext uri="{FF2B5EF4-FFF2-40B4-BE49-F238E27FC236}">
+                  <a16:creationId xmlns:a16="http://schemas.microsoft.com/office/drawing/2014/main" id="{79A7FD66-5EF6-9306-C625-07B242B31EA3}"/>
+                </a:ext>
+              </a:extLst>
+            </p:cNvPr>
+            <p:cNvCxnSpPr/>
+            <p:nvPr/>
+          </p:nvCxnSpPr>
+          <p:spPr>
+            <a:xfrm>
+              <a:off x="1376516" y="422789"/>
+              <a:ext cx="1229032" cy="0"/>
+            </a:xfrm>
+            <a:prstGeom prst="line">
+              <a:avLst/>
+            </a:prstGeom>
+            <a:ln w="3175">
+              <a:headEnd type="none" w="med" len="med"/>
+              <a:tailEnd type="triangle" w="med" len="med"/>
+            </a:ln>
+          </p:spPr>
+          <p:style>
+            <a:lnRef idx="3">
+              <a:schemeClr val="accent2"/>
+            </a:lnRef>
+            <a:fillRef idx="0">
+              <a:schemeClr val="accent2"/>
+            </a:fillRef>
+            <a:effectRef idx="2">
+              <a:schemeClr val="accent2"/>
+            </a:effectRef>
+            <a:fontRef idx="minor">
+              <a:schemeClr val="tx1"/>
+            </a:fontRef>
+          </p:style>
+        </p:cxnSp>
+        <p:sp>
+          <p:nvSpPr>
+            <p:cNvPr id="38" name="TextBox 37">
+              <a:extLst>
+                <a:ext uri="{FF2B5EF4-FFF2-40B4-BE49-F238E27FC236}">
+                  <a16:creationId xmlns:a16="http://schemas.microsoft.com/office/drawing/2014/main" id="{6BDE2E96-BCBB-20F9-C9CA-89FFC0DB40CF}"/>
+                </a:ext>
+              </a:extLst>
+            </p:cNvPr>
+            <p:cNvSpPr txBox="1"/>
+            <p:nvPr/>
+          </p:nvSpPr>
+          <p:spPr>
+            <a:xfrm>
+              <a:off x="1113814" y="284862"/>
+              <a:ext cx="280846" cy="307777"/>
+            </a:xfrm>
+            <a:prstGeom prst="rect">
+              <a:avLst/>
+            </a:prstGeom>
+            <a:noFill/>
+          </p:spPr>
+          <p:txBody>
+            <a:bodyPr wrap="none" rtlCol="0">
+              <a:spAutoFit/>
+            </a:bodyPr>
+            <a:lstStyle/>
+            <a:p>
+              <a:r>
+                <a:rPr lang="en-GB" sz="1400" dirty="0"/>
+                <a:t>4</a:t>
+              </a:r>
+            </a:p>
+          </p:txBody>
+        </p:sp>
+      </p:grpSp>
+      <p:grpSp>
+        <p:nvGrpSpPr>
+          <p:cNvPr id="39" name="Group 38">
+            <a:extLst>
+              <a:ext uri="{FF2B5EF4-FFF2-40B4-BE49-F238E27FC236}">
+                <a16:creationId xmlns:a16="http://schemas.microsoft.com/office/drawing/2014/main" id="{47D20F92-B922-A4E6-208F-F3370106AE9B}"/>
+              </a:ext>
+            </a:extLst>
+          </p:cNvPr>
+          <p:cNvGrpSpPr/>
+          <p:nvPr/>
+        </p:nvGrpSpPr>
+        <p:grpSpPr>
+          <a:xfrm>
+            <a:off x="4098526" y="1854262"/>
+            <a:ext cx="1491734" cy="307777"/>
+            <a:chOff x="1113814" y="284862"/>
+            <a:chExt cx="1491734" cy="307777"/>
+          </a:xfrm>
+        </p:grpSpPr>
+        <p:cxnSp>
+          <p:nvCxnSpPr>
+            <p:cNvPr id="40" name="Straight Connector 39">
+              <a:extLst>
+                <a:ext uri="{FF2B5EF4-FFF2-40B4-BE49-F238E27FC236}">
+                  <a16:creationId xmlns:a16="http://schemas.microsoft.com/office/drawing/2014/main" id="{FF7F77A6-46E8-929E-7720-997D64F16625}"/>
+                </a:ext>
+              </a:extLst>
+            </p:cNvPr>
+            <p:cNvCxnSpPr/>
+            <p:nvPr/>
+          </p:nvCxnSpPr>
+          <p:spPr>
+            <a:xfrm>
+              <a:off x="1376516" y="422789"/>
+              <a:ext cx="1229032" cy="0"/>
+            </a:xfrm>
+            <a:prstGeom prst="line">
+              <a:avLst/>
+            </a:prstGeom>
+            <a:ln w="3175">
+              <a:headEnd type="none" w="med" len="med"/>
+              <a:tailEnd type="triangle" w="med" len="med"/>
+            </a:ln>
+          </p:spPr>
+          <p:style>
+            <a:lnRef idx="3">
+              <a:schemeClr val="accent2"/>
+            </a:lnRef>
+            <a:fillRef idx="0">
+              <a:schemeClr val="accent2"/>
+            </a:fillRef>
+            <a:effectRef idx="2">
+              <a:schemeClr val="accent2"/>
+            </a:effectRef>
+            <a:fontRef idx="minor">
+              <a:schemeClr val="tx1"/>
+            </a:fontRef>
+          </p:style>
+        </p:cxnSp>
+        <p:sp>
+          <p:nvSpPr>
+            <p:cNvPr id="41" name="TextBox 40">
+              <a:extLst>
+                <a:ext uri="{FF2B5EF4-FFF2-40B4-BE49-F238E27FC236}">
+                  <a16:creationId xmlns:a16="http://schemas.microsoft.com/office/drawing/2014/main" id="{2B55D738-7977-DC92-7B34-601A506E3FC3}"/>
+                </a:ext>
+              </a:extLst>
+            </p:cNvPr>
+            <p:cNvSpPr txBox="1"/>
+            <p:nvPr/>
+          </p:nvSpPr>
+          <p:spPr>
+            <a:xfrm>
+              <a:off x="1113814" y="284862"/>
+              <a:ext cx="280846" cy="307777"/>
+            </a:xfrm>
+            <a:prstGeom prst="rect">
+              <a:avLst/>
+            </a:prstGeom>
+            <a:noFill/>
+          </p:spPr>
+          <p:txBody>
+            <a:bodyPr wrap="none" rtlCol="0">
+              <a:spAutoFit/>
+            </a:bodyPr>
+            <a:lstStyle/>
+            <a:p>
+              <a:r>
+                <a:rPr lang="en-GB" sz="1400" dirty="0"/>
+                <a:t>5</a:t>
+              </a:r>
+            </a:p>
+          </p:txBody>
+        </p:sp>
+      </p:grpSp>
+      <p:grpSp>
+        <p:nvGrpSpPr>
+          <p:cNvPr id="42" name="Group 41">
+            <a:extLst>
+              <a:ext uri="{FF2B5EF4-FFF2-40B4-BE49-F238E27FC236}">
+                <a16:creationId xmlns:a16="http://schemas.microsoft.com/office/drawing/2014/main" id="{38FB433B-3059-90D2-E7A3-12912B3DF39A}"/>
+              </a:ext>
+            </a:extLst>
+          </p:cNvPr>
+          <p:cNvGrpSpPr/>
+          <p:nvPr/>
+        </p:nvGrpSpPr>
+        <p:grpSpPr>
+          <a:xfrm>
+            <a:off x="3915522" y="2796947"/>
+            <a:ext cx="1030725" cy="307777"/>
+            <a:chOff x="1574823" y="268900"/>
+            <a:chExt cx="1030725" cy="307777"/>
+          </a:xfrm>
+        </p:grpSpPr>
+        <p:cxnSp>
+          <p:nvCxnSpPr>
+            <p:cNvPr id="43" name="Straight Connector 42">
+              <a:extLst>
+                <a:ext uri="{FF2B5EF4-FFF2-40B4-BE49-F238E27FC236}">
+                  <a16:creationId xmlns:a16="http://schemas.microsoft.com/office/drawing/2014/main" id="{4DFC886E-6394-B1B4-9144-41D48AFA0658}"/>
+                </a:ext>
+              </a:extLst>
+            </p:cNvPr>
+            <p:cNvCxnSpPr>
+              <a:cxnSpLocks/>
+            </p:cNvCxnSpPr>
+            <p:nvPr/>
+          </p:nvCxnSpPr>
+          <p:spPr>
+            <a:xfrm>
+              <a:off x="1952329" y="422789"/>
+              <a:ext cx="653219" cy="0"/>
+            </a:xfrm>
+            <a:prstGeom prst="line">
+              <a:avLst/>
+            </a:prstGeom>
+            <a:ln w="3175">
+              <a:headEnd type="none" w="med" len="med"/>
+              <a:tailEnd type="triangle" w="med" len="med"/>
+            </a:ln>
+          </p:spPr>
+          <p:style>
+            <a:lnRef idx="3">
+              <a:schemeClr val="accent2"/>
+            </a:lnRef>
+            <a:fillRef idx="0">
+              <a:schemeClr val="accent2"/>
+            </a:fillRef>
+            <a:effectRef idx="2">
+              <a:schemeClr val="accent2"/>
+            </a:effectRef>
+            <a:fontRef idx="minor">
+              <a:schemeClr val="tx1"/>
+            </a:fontRef>
+          </p:style>
+        </p:cxnSp>
+        <p:sp>
+          <p:nvSpPr>
+            <p:cNvPr id="44" name="TextBox 43">
+              <a:extLst>
+                <a:ext uri="{FF2B5EF4-FFF2-40B4-BE49-F238E27FC236}">
+                  <a16:creationId xmlns:a16="http://schemas.microsoft.com/office/drawing/2014/main" id="{8EFD2F7B-CC75-0C89-8EE3-FC4633D61C9D}"/>
+                </a:ext>
+              </a:extLst>
+            </p:cNvPr>
+            <p:cNvSpPr txBox="1"/>
+            <p:nvPr/>
+          </p:nvSpPr>
+          <p:spPr>
+            <a:xfrm>
+              <a:off x="1574823" y="268900"/>
+              <a:ext cx="434734" cy="307777"/>
+            </a:xfrm>
+            <a:prstGeom prst="rect">
+              <a:avLst/>
+            </a:prstGeom>
+            <a:noFill/>
+          </p:spPr>
+          <p:txBody>
+            <a:bodyPr wrap="none" rtlCol="0">
+              <a:spAutoFit/>
+            </a:bodyPr>
+            <a:lstStyle/>
+            <a:p>
+              <a:r>
+                <a:rPr lang="en-GB" sz="1400" dirty="0"/>
+                <a:t>6m</a:t>
+              </a:r>
+            </a:p>
+          </p:txBody>
+        </p:sp>
+      </p:grpSp>
+      <p:grpSp>
+        <p:nvGrpSpPr>
+          <p:cNvPr id="46" name="Group 45">
+            <a:extLst>
+              <a:ext uri="{FF2B5EF4-FFF2-40B4-BE49-F238E27FC236}">
+                <a16:creationId xmlns:a16="http://schemas.microsoft.com/office/drawing/2014/main" id="{5DDE4CC9-7077-8B65-0F4B-F5BC7F3B9078}"/>
+              </a:ext>
+            </a:extLst>
+          </p:cNvPr>
+          <p:cNvGrpSpPr/>
+          <p:nvPr/>
+        </p:nvGrpSpPr>
+        <p:grpSpPr>
+          <a:xfrm>
+            <a:off x="3920439" y="3263979"/>
+            <a:ext cx="1030725" cy="307777"/>
+            <a:chOff x="1574823" y="268900"/>
+            <a:chExt cx="1030725" cy="307777"/>
+          </a:xfrm>
+        </p:grpSpPr>
+        <p:cxnSp>
+          <p:nvCxnSpPr>
+            <p:cNvPr id="47" name="Straight Connector 46">
+              <a:extLst>
+                <a:ext uri="{FF2B5EF4-FFF2-40B4-BE49-F238E27FC236}">
+                  <a16:creationId xmlns:a16="http://schemas.microsoft.com/office/drawing/2014/main" id="{6B3D74E2-B2F2-1E8E-0B45-F587070626F0}"/>
+                </a:ext>
+              </a:extLst>
+            </p:cNvPr>
+            <p:cNvCxnSpPr>
+              <a:cxnSpLocks/>
+            </p:cNvCxnSpPr>
+            <p:nvPr/>
+          </p:nvCxnSpPr>
+          <p:spPr>
+            <a:xfrm>
+              <a:off x="1952329" y="422789"/>
+              <a:ext cx="653219" cy="0"/>
+            </a:xfrm>
+            <a:prstGeom prst="line">
+              <a:avLst/>
+            </a:prstGeom>
+            <a:ln w="3175">
+              <a:headEnd type="none" w="med" len="med"/>
+              <a:tailEnd type="triangle" w="med" len="med"/>
+            </a:ln>
+          </p:spPr>
+          <p:style>
+            <a:lnRef idx="3">
+              <a:schemeClr val="accent2"/>
+            </a:lnRef>
+            <a:fillRef idx="0">
+              <a:schemeClr val="accent2"/>
+            </a:fillRef>
+            <a:effectRef idx="2">
+              <a:schemeClr val="accent2"/>
+            </a:effectRef>
+            <a:fontRef idx="minor">
+              <a:schemeClr val="tx1"/>
+            </a:fontRef>
+          </p:style>
+        </p:cxnSp>
+        <p:sp>
+          <p:nvSpPr>
+            <p:cNvPr id="48" name="TextBox 47">
+              <a:extLst>
+                <a:ext uri="{FF2B5EF4-FFF2-40B4-BE49-F238E27FC236}">
+                  <a16:creationId xmlns:a16="http://schemas.microsoft.com/office/drawing/2014/main" id="{CC16344C-159E-D830-3493-7116C2A7AAF0}"/>
+                </a:ext>
+              </a:extLst>
+            </p:cNvPr>
+            <p:cNvSpPr txBox="1"/>
+            <p:nvPr/>
+          </p:nvSpPr>
+          <p:spPr>
+            <a:xfrm>
+              <a:off x="1574823" y="268900"/>
+              <a:ext cx="434734" cy="307777"/>
+            </a:xfrm>
+            <a:prstGeom prst="rect">
+              <a:avLst/>
+            </a:prstGeom>
+            <a:noFill/>
+          </p:spPr>
+          <p:txBody>
+            <a:bodyPr wrap="none" rtlCol="0">
+              <a:spAutoFit/>
+            </a:bodyPr>
+            <a:lstStyle/>
+            <a:p>
+              <a:r>
+                <a:rPr lang="en-GB" sz="1400" dirty="0"/>
+                <a:t>2m</a:t>
+              </a:r>
+            </a:p>
+          </p:txBody>
+        </p:sp>
+      </p:grpSp>
+      <p:grpSp>
+        <p:nvGrpSpPr>
+          <p:cNvPr id="49" name="Group 48">
+            <a:extLst>
+              <a:ext uri="{FF2B5EF4-FFF2-40B4-BE49-F238E27FC236}">
+                <a16:creationId xmlns:a16="http://schemas.microsoft.com/office/drawing/2014/main" id="{148EDDFE-999E-6A35-A55D-B327B13EA380}"/>
+              </a:ext>
+            </a:extLst>
+          </p:cNvPr>
+          <p:cNvGrpSpPr/>
+          <p:nvPr/>
+        </p:nvGrpSpPr>
+        <p:grpSpPr>
+          <a:xfrm>
+            <a:off x="4123106" y="2596598"/>
+            <a:ext cx="1491734" cy="307777"/>
+            <a:chOff x="1113814" y="284862"/>
+            <a:chExt cx="1491734" cy="307777"/>
+          </a:xfrm>
+        </p:grpSpPr>
+        <p:cxnSp>
+          <p:nvCxnSpPr>
+            <p:cNvPr id="50" name="Straight Connector 49">
+              <a:extLst>
+                <a:ext uri="{FF2B5EF4-FFF2-40B4-BE49-F238E27FC236}">
+                  <a16:creationId xmlns:a16="http://schemas.microsoft.com/office/drawing/2014/main" id="{21EEAF91-87F3-F29C-5932-08DA1DE0EE41}"/>
+                </a:ext>
+              </a:extLst>
+            </p:cNvPr>
+            <p:cNvCxnSpPr/>
+            <p:nvPr/>
+          </p:nvCxnSpPr>
+          <p:spPr>
+            <a:xfrm>
+              <a:off x="1376516" y="422789"/>
+              <a:ext cx="1229032" cy="0"/>
+            </a:xfrm>
+            <a:prstGeom prst="line">
+              <a:avLst/>
+            </a:prstGeom>
+            <a:ln w="3175">
+              <a:headEnd type="none" w="med" len="med"/>
+              <a:tailEnd type="triangle" w="med" len="med"/>
+            </a:ln>
+          </p:spPr>
+          <p:style>
+            <a:lnRef idx="3">
+              <a:schemeClr val="accent2"/>
+            </a:lnRef>
+            <a:fillRef idx="0">
+              <a:schemeClr val="accent2"/>
+            </a:fillRef>
+            <a:effectRef idx="2">
+              <a:schemeClr val="accent2"/>
+            </a:effectRef>
+            <a:fontRef idx="minor">
+              <a:schemeClr val="tx1"/>
+            </a:fontRef>
+          </p:style>
+        </p:cxnSp>
+        <p:sp>
+          <p:nvSpPr>
+            <p:cNvPr id="51" name="TextBox 50">
+              <a:extLst>
+                <a:ext uri="{FF2B5EF4-FFF2-40B4-BE49-F238E27FC236}">
+                  <a16:creationId xmlns:a16="http://schemas.microsoft.com/office/drawing/2014/main" id="{39FCCAF1-1BA0-1BFA-4F06-1A8674E9E8F8}"/>
+                </a:ext>
+              </a:extLst>
+            </p:cNvPr>
+            <p:cNvSpPr txBox="1"/>
+            <p:nvPr/>
+          </p:nvSpPr>
+          <p:spPr>
+            <a:xfrm>
+              <a:off x="1113814" y="284862"/>
+              <a:ext cx="280846" cy="307777"/>
+            </a:xfrm>
+            <a:prstGeom prst="rect">
+              <a:avLst/>
+            </a:prstGeom>
+            <a:noFill/>
+          </p:spPr>
+          <p:txBody>
+            <a:bodyPr wrap="none" rtlCol="0">
+              <a:spAutoFit/>
+            </a:bodyPr>
+            <a:lstStyle/>
+            <a:p>
+              <a:r>
+                <a:rPr lang="en-GB" sz="1400" dirty="0"/>
+                <a:t>1</a:t>
+              </a:r>
+            </a:p>
+          </p:txBody>
+        </p:sp>
+      </p:grpSp>
+      <p:grpSp>
+        <p:nvGrpSpPr>
+          <p:cNvPr id="52" name="Group 51">
+            <a:extLst>
+              <a:ext uri="{FF2B5EF4-FFF2-40B4-BE49-F238E27FC236}">
+                <a16:creationId xmlns:a16="http://schemas.microsoft.com/office/drawing/2014/main" id="{F399101B-A7D2-4CC8-F861-A44563CB8E03}"/>
+              </a:ext>
+            </a:extLst>
+          </p:cNvPr>
+          <p:cNvGrpSpPr/>
+          <p:nvPr/>
+        </p:nvGrpSpPr>
+        <p:grpSpPr>
+          <a:xfrm>
+            <a:off x="4044946" y="1308847"/>
+            <a:ext cx="1560064" cy="307777"/>
+            <a:chOff x="1045484" y="294971"/>
+            <a:chExt cx="1560064" cy="307777"/>
+          </a:xfrm>
+        </p:grpSpPr>
+        <p:cxnSp>
+          <p:nvCxnSpPr>
+            <p:cNvPr id="53" name="Straight Connector 52">
+              <a:extLst>
+                <a:ext uri="{FF2B5EF4-FFF2-40B4-BE49-F238E27FC236}">
+                  <a16:creationId xmlns:a16="http://schemas.microsoft.com/office/drawing/2014/main" id="{0048A250-4745-57CD-8903-514B42E30B74}"/>
+                </a:ext>
+              </a:extLst>
+            </p:cNvPr>
+            <p:cNvCxnSpPr/>
+            <p:nvPr/>
+          </p:nvCxnSpPr>
+          <p:spPr>
+            <a:xfrm>
+              <a:off x="1376516" y="422789"/>
+              <a:ext cx="1229032" cy="0"/>
+            </a:xfrm>
+            <a:prstGeom prst="line">
+              <a:avLst/>
+            </a:prstGeom>
+            <a:ln w="3175">
+              <a:headEnd type="none" w="med" len="med"/>
+              <a:tailEnd type="triangle" w="med" len="med"/>
+            </a:ln>
+          </p:spPr>
+          <p:style>
+            <a:lnRef idx="3">
+              <a:schemeClr val="accent2"/>
+            </a:lnRef>
+            <a:fillRef idx="0">
+              <a:schemeClr val="accent2"/>
+            </a:fillRef>
+            <a:effectRef idx="2">
+              <a:schemeClr val="accent2"/>
+            </a:effectRef>
+            <a:fontRef idx="minor">
+              <a:schemeClr val="tx1"/>
+            </a:fontRef>
+          </p:style>
+        </p:cxnSp>
+        <p:sp>
+          <p:nvSpPr>
+            <p:cNvPr id="54" name="TextBox 53">
+              <a:extLst>
+                <a:ext uri="{FF2B5EF4-FFF2-40B4-BE49-F238E27FC236}">
+                  <a16:creationId xmlns:a16="http://schemas.microsoft.com/office/drawing/2014/main" id="{93CBA4F8-8894-5670-15DB-216870DF2E46}"/>
+                </a:ext>
+              </a:extLst>
+            </p:cNvPr>
+            <p:cNvSpPr txBox="1"/>
+            <p:nvPr/>
+          </p:nvSpPr>
+          <p:spPr>
+            <a:xfrm>
+              <a:off x="1045484" y="294971"/>
+              <a:ext cx="381836" cy="307777"/>
+            </a:xfrm>
+            <a:prstGeom prst="rect">
+              <a:avLst/>
+            </a:prstGeom>
+            <a:noFill/>
+          </p:spPr>
+          <p:txBody>
+            <a:bodyPr wrap="none" rtlCol="0">
+              <a:spAutoFit/>
+            </a:bodyPr>
+            <a:lstStyle/>
+            <a:p>
+              <a:r>
+                <a:rPr lang="en-GB" sz="1400" dirty="0"/>
+                <a:t>5b</a:t>
+              </a:r>
+            </a:p>
+          </p:txBody>
+        </p:sp>
+      </p:grpSp>
+      <p:sp>
+        <p:nvSpPr>
+          <p:cNvPr id="55" name="TextBox 54">
+            <a:extLst>
+              <a:ext uri="{FF2B5EF4-FFF2-40B4-BE49-F238E27FC236}">
+                <a16:creationId xmlns:a16="http://schemas.microsoft.com/office/drawing/2014/main" id="{A3C8400C-4EFA-E9E4-9F72-93910BD91BF3}"/>
+              </a:ext>
+            </a:extLst>
+          </p:cNvPr>
+          <p:cNvSpPr txBox="1"/>
+          <p:nvPr/>
+        </p:nvSpPr>
+        <p:spPr>
+          <a:xfrm>
+            <a:off x="3086620" y="4915809"/>
+            <a:ext cx="3124702" cy="738664"/>
+          </a:xfrm>
+          <a:prstGeom prst="rect">
+            <a:avLst/>
+          </a:prstGeom>
+          <a:noFill/>
+        </p:spPr>
+        <p:txBody>
+          <a:bodyPr wrap="none" rtlCol="0">
+            <a:spAutoFit/>
+          </a:bodyPr>
+          <a:lstStyle/>
+          <a:p>
+            <a:r>
+              <a:rPr lang="en-GB" sz="1400" dirty="0"/>
+              <a:t>Backspace + 1 – Mute/unmute Drums</a:t>
+            </a:r>
+          </a:p>
+          <a:p>
+            <a:r>
+              <a:rPr lang="en-GB" sz="1400" dirty="0"/>
+              <a:t>Backspace + 2 – Mute/unmute Bass</a:t>
+            </a:r>
+          </a:p>
+          <a:p>
+            <a:r>
+              <a:rPr lang="en-GB" sz="1400" dirty="0"/>
+              <a:t>Backspace + 3 – Mute/unmute Chords</a:t>
+            </a:r>
+          </a:p>
+        </p:txBody>
+      </p:sp>
+      <p:sp>
+        <p:nvSpPr>
+          <p:cNvPr id="56" name="TextBox 55">
+            <a:extLst>
+              <a:ext uri="{FF2B5EF4-FFF2-40B4-BE49-F238E27FC236}">
+                <a16:creationId xmlns:a16="http://schemas.microsoft.com/office/drawing/2014/main" id="{7F184DA2-BD29-698E-86A8-D98F20A899EE}"/>
+              </a:ext>
+            </a:extLst>
+          </p:cNvPr>
+          <p:cNvSpPr txBox="1"/>
+          <p:nvPr/>
+        </p:nvSpPr>
+        <p:spPr>
+          <a:xfrm>
+            <a:off x="6631158" y="4920723"/>
+            <a:ext cx="1614801" cy="1384995"/>
+          </a:xfrm>
+          <a:prstGeom prst="rect">
+            <a:avLst/>
+          </a:prstGeom>
+          <a:noFill/>
+        </p:spPr>
+        <p:txBody>
+          <a:bodyPr wrap="none" rtlCol="0">
+            <a:spAutoFit/>
+          </a:bodyPr>
+          <a:lstStyle/>
+          <a:p>
+            <a:r>
+              <a:rPr lang="en-GB" sz="1400" dirty="0"/>
+              <a:t>Keys 7 + 8  is 3 </a:t>
+            </a:r>
+            <a:r>
+              <a:rPr lang="en-GB" sz="1400" dirty="0" err="1"/>
+              <a:t>maj</a:t>
+            </a:r>
+            <a:endParaRPr lang="en-GB" sz="1400" dirty="0"/>
+          </a:p>
+          <a:p>
+            <a:r>
+              <a:rPr lang="en-GB" sz="1400" dirty="0"/>
+              <a:t>Keys 1 + 2  is 2 </a:t>
+            </a:r>
+            <a:r>
+              <a:rPr lang="en-GB" sz="1400" dirty="0" err="1"/>
+              <a:t>maj</a:t>
+            </a:r>
+            <a:br>
+              <a:rPr lang="en-GB" sz="1400" dirty="0"/>
+            </a:br>
+            <a:r>
+              <a:rPr lang="en-GB" sz="1400" dirty="0"/>
+              <a:t>Keys 4 + 5  is 6 </a:t>
+            </a:r>
+            <a:r>
+              <a:rPr lang="en-GB" sz="1400" dirty="0" err="1"/>
+              <a:t>maj</a:t>
+            </a:r>
+            <a:endParaRPr lang="en-GB" sz="1400" dirty="0"/>
+          </a:p>
+          <a:p>
+            <a:r>
+              <a:rPr lang="en-GB" sz="1400" dirty="0"/>
+              <a:t>Keys 5 + 6  is 1 sus</a:t>
+            </a:r>
+          </a:p>
+          <a:p>
+            <a:r>
+              <a:rPr lang="en-GB" sz="1400" dirty="0"/>
+              <a:t>Keys 8 + 9  is 5 sus</a:t>
+            </a:r>
+          </a:p>
+          <a:p>
+            <a:r>
+              <a:rPr lang="en-GB" sz="1400" dirty="0"/>
+              <a:t>Keys 2 + 3  is 4 min</a:t>
+            </a:r>
+          </a:p>
+        </p:txBody>
+      </p:sp>
+      <p:grpSp>
+        <p:nvGrpSpPr>
+          <p:cNvPr id="57" name="Group 56">
+            <a:extLst>
+              <a:ext uri="{FF2B5EF4-FFF2-40B4-BE49-F238E27FC236}">
+                <a16:creationId xmlns:a16="http://schemas.microsoft.com/office/drawing/2014/main" id="{561406B2-F58C-3448-342E-59BF286D1568}"/>
+              </a:ext>
+            </a:extLst>
+          </p:cNvPr>
+          <p:cNvGrpSpPr/>
+          <p:nvPr/>
+        </p:nvGrpSpPr>
+        <p:grpSpPr>
+          <a:xfrm>
+            <a:off x="3910606" y="2123433"/>
+            <a:ext cx="1030725" cy="307777"/>
+            <a:chOff x="1574823" y="268900"/>
+            <a:chExt cx="1030725" cy="307777"/>
+          </a:xfrm>
+        </p:grpSpPr>
+        <p:cxnSp>
+          <p:nvCxnSpPr>
+            <p:cNvPr id="58" name="Straight Connector 57">
+              <a:extLst>
+                <a:ext uri="{FF2B5EF4-FFF2-40B4-BE49-F238E27FC236}">
+                  <a16:creationId xmlns:a16="http://schemas.microsoft.com/office/drawing/2014/main" id="{8D02B32F-E1EF-7C10-95F0-7F1620190B30}"/>
+                </a:ext>
+              </a:extLst>
+            </p:cNvPr>
+            <p:cNvCxnSpPr>
+              <a:cxnSpLocks/>
+            </p:cNvCxnSpPr>
+            <p:nvPr/>
+          </p:nvCxnSpPr>
+          <p:spPr>
+            <a:xfrm>
+              <a:off x="1952329" y="422789"/>
+              <a:ext cx="653219" cy="0"/>
+            </a:xfrm>
+            <a:prstGeom prst="line">
+              <a:avLst/>
+            </a:prstGeom>
+            <a:ln w="3175">
+              <a:headEnd type="none" w="med" len="med"/>
+              <a:tailEnd type="triangle" w="med" len="med"/>
+            </a:ln>
+          </p:spPr>
+          <p:style>
+            <a:lnRef idx="3">
+              <a:schemeClr val="accent2"/>
+            </a:lnRef>
+            <a:fillRef idx="0">
+              <a:schemeClr val="accent2"/>
+            </a:fillRef>
+            <a:effectRef idx="2">
+              <a:schemeClr val="accent2"/>
+            </a:effectRef>
+            <a:fontRef idx="minor">
+              <a:schemeClr val="tx1"/>
+            </a:fontRef>
+          </p:style>
+        </p:cxnSp>
+        <p:sp>
+          <p:nvSpPr>
+            <p:cNvPr id="59" name="TextBox 58">
+              <a:extLst>
+                <a:ext uri="{FF2B5EF4-FFF2-40B4-BE49-F238E27FC236}">
+                  <a16:creationId xmlns:a16="http://schemas.microsoft.com/office/drawing/2014/main" id="{6E89A952-7485-1BF6-1453-FE7ED6E88750}"/>
+                </a:ext>
+              </a:extLst>
+            </p:cNvPr>
+            <p:cNvSpPr txBox="1"/>
+            <p:nvPr/>
+          </p:nvSpPr>
+          <p:spPr>
+            <a:xfrm>
+              <a:off x="1574823" y="268900"/>
+              <a:ext cx="434734" cy="307777"/>
+            </a:xfrm>
+            <a:prstGeom prst="rect">
+              <a:avLst/>
+            </a:prstGeom>
+            <a:noFill/>
+          </p:spPr>
+          <p:txBody>
+            <a:bodyPr wrap="none" rtlCol="0">
+              <a:spAutoFit/>
+            </a:bodyPr>
+            <a:lstStyle/>
+            <a:p>
+              <a:r>
+                <a:rPr lang="en-GB" sz="1400" dirty="0"/>
+                <a:t>3m</a:t>
+              </a:r>
+            </a:p>
+          </p:txBody>
+        </p:sp>
+      </p:grpSp>
+    </p:spTree>
+    <p:extLst>
+      <p:ext uri="{BB962C8B-B14F-4D97-AF65-F5344CB8AC3E}">
+        <p14:creationId xmlns:p14="http://schemas.microsoft.com/office/powerpoint/2010/main" val="2246666719"/>
+      </p:ext>
+    </p:extLst>
+  </p:cSld>
+  <p:clrMapOvr>
+    <a:masterClrMapping/>
+  </p:clrMapOvr>
+</p:sld>
+</file>
+
 <file path=ppt/theme/theme1.xml><?xml version="1.0" encoding="utf-8"?>
 <a:theme xmlns:a="http://schemas.openxmlformats.org/drawingml/2006/main" name="Office Theme">
   <a:themeElements>
@@ -10481,4 +12648,319 @@
     </a:ext>
   </a:extLst>
 </a:theme>
+</file>
+
+<file path=ppt/theme/theme2.xml><?xml version="1.0" encoding="utf-8"?>
+<a:theme xmlns:a="http://schemas.openxmlformats.org/drawingml/2006/main" name="Office Theme">
+  <a:themeElements>
+    <a:clrScheme name="Office">
+      <a:dk1>
+        <a:sysClr val="windowText" lastClr="000000"/>
+      </a:dk1>
+      <a:lt1>
+        <a:sysClr val="window" lastClr="FFFFFF"/>
+      </a:lt1>
+      <a:dk2>
+        <a:srgbClr val="0E2841"/>
+      </a:dk2>
+      <a:lt2>
+        <a:srgbClr val="E8E8E8"/>
+      </a:lt2>
+      <a:accent1>
+        <a:srgbClr val="156082"/>
+      </a:accent1>
+      <a:accent2>
+        <a:srgbClr val="E97132"/>
+      </a:accent2>
+      <a:accent3>
+        <a:srgbClr val="196B24"/>
+      </a:accent3>
+      <a:accent4>
+        <a:srgbClr val="0F9ED5"/>
+      </a:accent4>
+      <a:accent5>
+        <a:srgbClr val="A02B93"/>
+      </a:accent5>
+      <a:accent6>
+        <a:srgbClr val="4EA72E"/>
+      </a:accent6>
+      <a:hlink>
+        <a:srgbClr val="467886"/>
+      </a:hlink>
+      <a:folHlink>
+        <a:srgbClr val="96607D"/>
+      </a:folHlink>
+    </a:clrScheme>
+    <a:fontScheme name="Office">
+      <a:majorFont>
+        <a:latin typeface="Aptos Display" panose="02110004020202020204"/>
+        <a:ea typeface=""/>
+        <a:cs typeface=""/>
+        <a:font script="Jpan" typeface="游ゴシック Light"/>
+        <a:font script="Hang" typeface="맑은 고딕"/>
+        <a:font script="Hans" typeface="等线 Light"/>
+        <a:font script="Hant" typeface="新細明體"/>
+        <a:font script="Arab" typeface="Times New Roman"/>
+        <a:font script="Hebr" typeface="Times New Roman"/>
+        <a:font script="Thai" typeface="Angsana New"/>
+        <a:font script="Ethi" typeface="Nyala"/>
+        <a:font script="Beng" typeface="Vrinda"/>
+        <a:font script="Gujr" typeface="Shruti"/>
+        <a:font script="Khmr" typeface="MoolBoran"/>
+        <a:font script="Knda" typeface="Tunga"/>
+        <a:font script="Guru" typeface="Raavi"/>
+        <a:font script="Cans" typeface="Euphemia"/>
+        <a:font script="Cher" typeface="Plantagenet Cherokee"/>
+        <a:font script="Yiii" typeface="Microsoft Yi Baiti"/>
+        <a:font script="Tibt" typeface="Microsoft Himalaya"/>
+        <a:font script="Thaa" typeface="MV Boli"/>
+        <a:font script="Deva" typeface="Mangal"/>
+        <a:font script="Telu" typeface="Gautami"/>
+        <a:font script="Taml" typeface="Latha"/>
+        <a:font script="Syrc" typeface="Estrangelo Edessa"/>
+        <a:font script="Orya" typeface="Kalinga"/>
+        <a:font script="Mlym" typeface="Kartika"/>
+        <a:font script="Laoo" typeface="DokChampa"/>
+        <a:font script="Sinh" typeface="Iskoola Pota"/>
+        <a:font script="Mong" typeface="Mongolian Baiti"/>
+        <a:font script="Viet" typeface="Times New Roman"/>
+        <a:font script="Uigh" typeface="Microsoft Uighur"/>
+        <a:font script="Geor" typeface="Sylfaen"/>
+        <a:font script="Armn" typeface="Arial"/>
+        <a:font script="Bugi" typeface="Leelawadee UI"/>
+        <a:font script="Bopo" typeface="Microsoft JhengHei"/>
+        <a:font script="Java" typeface="Javanese Text"/>
+        <a:font script="Lisu" typeface="Segoe UI"/>
+        <a:font script="Mymr" typeface="Myanmar Text"/>
+        <a:font script="Nkoo" typeface="Ebrima"/>
+        <a:font script="Olck" typeface="Nirmala UI"/>
+        <a:font script="Osma" typeface="Ebrima"/>
+        <a:font script="Phag" typeface="Phagspa"/>
+        <a:font script="Syrn" typeface="Estrangelo Edessa"/>
+        <a:font script="Syrj" typeface="Estrangelo Edessa"/>
+        <a:font script="Syre" typeface="Estrangelo Edessa"/>
+        <a:font script="Sora" typeface="Nirmala UI"/>
+        <a:font script="Tale" typeface="Microsoft Tai Le"/>
+        <a:font script="Talu" typeface="Microsoft New Tai Lue"/>
+        <a:font script="Tfng" typeface="Ebrima"/>
+      </a:majorFont>
+      <a:minorFont>
+        <a:latin typeface="Aptos" panose="02110004020202020204"/>
+        <a:ea typeface=""/>
+        <a:cs typeface=""/>
+        <a:font script="Jpan" typeface="游ゴシック"/>
+        <a:font script="Hang" typeface="맑은 고딕"/>
+        <a:font script="Hans" typeface="等线"/>
+        <a:font script="Hant" typeface="新細明體"/>
+        <a:font script="Arab" typeface="Arial"/>
+        <a:font script="Hebr" typeface="Arial"/>
+        <a:font script="Thai" typeface="Cordia New"/>
+        <a:font script="Ethi" typeface="Nyala"/>
+        <a:font script="Beng" typeface="Vrinda"/>
+        <a:font script="Gujr" typeface="Shruti"/>
+        <a:font script="Khmr" typeface="DaunPenh"/>
+        <a:font script="Knda" typeface="Tunga"/>
+        <a:font script="Guru" typeface="Raavi"/>
+        <a:font script="Cans" typeface="Euphemia"/>
+        <a:font script="Cher" typeface="Plantagenet Cherokee"/>
+        <a:font script="Yiii" typeface="Microsoft Yi Baiti"/>
+        <a:font script="Tibt" typeface="Microsoft Himalaya"/>
+        <a:font script="Thaa" typeface="MV Boli"/>
+        <a:font script="Deva" typeface="Mangal"/>
+        <a:font script="Telu" typeface="Gautami"/>
+        <a:font script="Taml" typeface="Latha"/>
+        <a:font script="Syrc" typeface="Estrangelo Edessa"/>
+        <a:font script="Orya" typeface="Kalinga"/>
+        <a:font script="Mlym" typeface="Kartika"/>
+        <a:font script="Laoo" typeface="DokChampa"/>
+        <a:font script="Sinh" typeface="Iskoola Pota"/>
+        <a:font script="Mong" typeface="Mongolian Baiti"/>
+        <a:font script="Viet" typeface="Arial"/>
+        <a:font script="Uigh" typeface="Microsoft Uighur"/>
+        <a:font script="Geor" typeface="Sylfaen"/>
+        <a:font script="Armn" typeface="Arial"/>
+        <a:font script="Bugi" typeface="Leelawadee UI"/>
+        <a:font script="Bopo" typeface="Microsoft JhengHei"/>
+        <a:font script="Java" typeface="Javanese Text"/>
+        <a:font script="Lisu" typeface="Segoe UI"/>
+        <a:font script="Mymr" typeface="Myanmar Text"/>
+        <a:font script="Nkoo" typeface="Ebrima"/>
+        <a:font script="Olck" typeface="Nirmala UI"/>
+        <a:font script="Osma" typeface="Ebrima"/>
+        <a:font script="Phag" typeface="Phagspa"/>
+        <a:font script="Syrn" typeface="Estrangelo Edessa"/>
+        <a:font script="Syrj" typeface="Estrangelo Edessa"/>
+        <a:font script="Syre" typeface="Estrangelo Edessa"/>
+        <a:font script="Sora" typeface="Nirmala UI"/>
+        <a:font script="Tale" typeface="Microsoft Tai Le"/>
+        <a:font script="Talu" typeface="Microsoft New Tai Lue"/>
+        <a:font script="Tfng" typeface="Ebrima"/>
+      </a:minorFont>
+    </a:fontScheme>
+    <a:fmtScheme name="Office">
+      <a:fillStyleLst>
+        <a:solidFill>
+          <a:schemeClr val="phClr"/>
+        </a:solidFill>
+        <a:gradFill rotWithShape="1">
+          <a:gsLst>
+            <a:gs pos="0">
+              <a:schemeClr val="phClr">
+                <a:lumMod val="110000"/>
+                <a:satMod val="105000"/>
+                <a:tint val="67000"/>
+              </a:schemeClr>
+            </a:gs>
+            <a:gs pos="50000">
+              <a:schemeClr val="phClr">
+                <a:lumMod val="105000"/>
+                <a:satMod val="103000"/>
+                <a:tint val="73000"/>
+              </a:schemeClr>
+            </a:gs>
+            <a:gs pos="100000">
+              <a:schemeClr val="phClr">
+                <a:lumMod val="105000"/>
+                <a:satMod val="109000"/>
+                <a:tint val="81000"/>
+              </a:schemeClr>
+            </a:gs>
+          </a:gsLst>
+          <a:lin ang="5400000" scaled="0"/>
+        </a:gradFill>
+        <a:gradFill rotWithShape="1">
+          <a:gsLst>
+            <a:gs pos="0">
+              <a:schemeClr val="phClr">
+                <a:satMod val="103000"/>
+                <a:lumMod val="102000"/>
+                <a:tint val="94000"/>
+              </a:schemeClr>
+            </a:gs>
+            <a:gs pos="50000">
+              <a:schemeClr val="phClr">
+                <a:satMod val="110000"/>
+                <a:lumMod val="100000"/>
+                <a:shade val="100000"/>
+              </a:schemeClr>
+            </a:gs>
+            <a:gs pos="100000">
+              <a:schemeClr val="phClr">
+                <a:lumMod val="99000"/>
+                <a:satMod val="120000"/>
+                <a:shade val="78000"/>
+              </a:schemeClr>
+            </a:gs>
+          </a:gsLst>
+          <a:lin ang="5400000" scaled="0"/>
+        </a:gradFill>
+      </a:fillStyleLst>
+      <a:lnStyleLst>
+        <a:ln w="12700" cap="flat" cmpd="sng" algn="ctr">
+          <a:solidFill>
+            <a:schemeClr val="phClr"/>
+          </a:solidFill>
+          <a:prstDash val="solid"/>
+          <a:miter lim="800000"/>
+        </a:ln>
+        <a:ln w="19050" cap="flat" cmpd="sng" algn="ctr">
+          <a:solidFill>
+            <a:schemeClr val="phClr"/>
+          </a:solidFill>
+          <a:prstDash val="solid"/>
+          <a:miter lim="800000"/>
+        </a:ln>
+        <a:ln w="25400" cap="flat" cmpd="sng" algn="ctr">
+          <a:solidFill>
+            <a:schemeClr val="phClr"/>
+          </a:solidFill>
+          <a:prstDash val="solid"/>
+          <a:miter lim="800000"/>
+        </a:ln>
+      </a:lnStyleLst>
+      <a:effectStyleLst>
+        <a:effectStyle>
+          <a:effectLst/>
+        </a:effectStyle>
+        <a:effectStyle>
+          <a:effectLst/>
+        </a:effectStyle>
+        <a:effectStyle>
+          <a:effectLst>
+            <a:outerShdw blurRad="57150" dist="19050" dir="5400000" algn="ctr" rotWithShape="0">
+              <a:srgbClr val="000000">
+                <a:alpha val="63000"/>
+              </a:srgbClr>
+            </a:outerShdw>
+          </a:effectLst>
+        </a:effectStyle>
+      </a:effectStyleLst>
+      <a:bgFillStyleLst>
+        <a:solidFill>
+          <a:schemeClr val="phClr"/>
+        </a:solidFill>
+        <a:solidFill>
+          <a:schemeClr val="phClr">
+            <a:tint val="95000"/>
+            <a:satMod val="170000"/>
+          </a:schemeClr>
+        </a:solidFill>
+        <a:gradFill rotWithShape="1">
+          <a:gsLst>
+            <a:gs pos="0">
+              <a:schemeClr val="phClr">
+                <a:tint val="93000"/>
+                <a:satMod val="150000"/>
+                <a:shade val="98000"/>
+                <a:lumMod val="102000"/>
+              </a:schemeClr>
+            </a:gs>
+            <a:gs pos="50000">
+              <a:schemeClr val="phClr">
+                <a:tint val="98000"/>
+                <a:satMod val="130000"/>
+                <a:shade val="90000"/>
+                <a:lumMod val="103000"/>
+              </a:schemeClr>
+            </a:gs>
+            <a:gs pos="100000">
+              <a:schemeClr val="phClr">
+                <a:shade val="63000"/>
+                <a:satMod val="120000"/>
+              </a:schemeClr>
+            </a:gs>
+          </a:gsLst>
+          <a:lin ang="5400000" scaled="0"/>
+        </a:gradFill>
+      </a:bgFillStyleLst>
+    </a:fmtScheme>
+  </a:themeElements>
+  <a:objectDefaults>
+    <a:lnDef>
+      <a:spPr/>
+      <a:bodyPr/>
+      <a:lstStyle/>
+      <a:style>
+        <a:lnRef idx="2">
+          <a:schemeClr val="accent1"/>
+        </a:lnRef>
+        <a:fillRef idx="0">
+          <a:schemeClr val="accent1"/>
+        </a:fillRef>
+        <a:effectRef idx="1">
+          <a:schemeClr val="accent1"/>
+        </a:effectRef>
+        <a:fontRef idx="minor">
+          <a:schemeClr val="tx1"/>
+        </a:fontRef>
+      </a:style>
+    </a:lnDef>
+  </a:objectDefaults>
+  <a:extraClrSchemeLst/>
+  <a:extLst>
+    <a:ext uri="{05A4C25C-085E-4340-85A3-A5531E510DB2}">
+      <thm15:themeFamily xmlns:thm15="http://schemas.microsoft.com/office/thememl/2012/main" name="Office Theme" id="{2E142A2C-CD16-42D6-873A-C26D2A0506FA}" vid="{1BDDFF52-6CD6-40A5-AB3C-68EB2F1E4D0A}"/>
+    </a:ext>
+  </a:extLst>
+</a:theme>
 </file>
</xml_diff>